<commit_message>
Add AR glasses story: why now, workbench AR, learning loop, device strategy
- Tora deck (22 slides): background (AI moves from office work to the worker's eyes and hands),
  workbench AR (full-size drawings at the joint, mistake-prone points, eye protection, limits),
  learning loop (veterans teach the AI to interpret scenes), device strategy (buy rugged
  commercial devices, do not build glasses)
- Easy deck: new episode on drawings at hand and the red/blue wire moment
- Proof deck: device conditions, candidate specs and the AR pilot design; Q&A and sources
- Smart glasses benefits and requirements note, Q&A 25-28

Co-Authored-By: Claude Opus 5.5 <noreply@anthropic.com>
Claude-Session: https://claude.ai/code/session_01Lvjvqoc8h4yHt4F4M6n1V9
</commit_message>
<xml_diff>
--- a/deck/令和の虎_理論武装版_数字の根拠.pptx
+++ b/deck/令和の虎_理論武装版_数字の根拠.pptx
@@ -20,9 +20,10 @@
     <p:sldId id="268" r:id="rId14"/>
     <p:sldId id="269" r:id="rId15"/>
     <p:sldId id="270" r:id="rId16"/>
+    <p:sldId id="271" r:id="rId17"/>
   </p:sldIdLst>
   <p:notesMasterIdLst>
-    <p:notesMasterId r:id="rId17"/>
+    <p:notesMasterId r:id="rId18"/>
   </p:notesMasterIdLst>
   <p:sldSz cx="9144000" cy="5143500"/>
   <p:notesSz cx="5143500" cy="9144000"/>
@@ -967,8 +968,8 @@
             <a:r>
               <a:rPr lang="en-US" dirty="0"/>
               <a:t>【根拠13】
-要約：厳しい質問には、数字→式→前提の順で答える
-厳しい質問への回答集です。それぞれ、一言の答えと、根拠のページを書いています。</a:t>
+要約：グラスは作らず選ぶ。手元ARの効果は3つの数字で実測する
+端末と実証の設計です。グラス本体は開発しません。落下・防じん防水・電池・ヘルメット・手袋での操作という現場の条件で市販の端末を選び、乗り換えられる設計にします。手元ARの効果は、よく使うジョイント1種類で、手戻りの件数、1ジョイントの作業時間、新人が独り立ちするまでの期間の3つで測ります。</a:t>
             </a:r>
             <a:endParaRPr lang="en-US" dirty="0"/>
           </a:p>
@@ -1056,6 +1057,96 @@
           <a:p>
             <a:r>
               <a:rPr lang="en-US" dirty="0"/>
+              <a:t>【根拠14】
+要約：厳しい質問には、数字→式→前提の順で答える
+厳しい質問への回答集です。それぞれ、一言の答えと、根拠のページを書いています。</a:t>
+            </a:r>
+            <a:endParaRPr lang="en-US" dirty="0"/>
+          </a:p>
+        </p:txBody>
+      </p:sp>
+      <p:sp>
+        <p:nvSpPr>
+          <p:cNvPr id="4" name="Slide Number Placeholder 3"/>
+          <p:cNvSpPr>
+            <a:spLocks noGrp="1"/>
+          </p:cNvSpPr>
+          <p:nvPr>
+            <p:ph type="sldNum" sz="quarter" idx="10"/>
+          </p:nvPr>
+        </p:nvSpPr>
+        <p:spPr/>
+        <p:txBody>
+          <a:bodyPr/>
+          <a:lstStyle/>
+          <a:p>
+            <a:fld id="{F7021451-1387-4CA6-816F-3879F97B5CBC}" type="slidenum">
+              <a:rPr lang="en-US"/>
+              <a:t>15</a:t>
+            </a:fld>
+            <a:endParaRPr lang="en-US"/>
+          </a:p>
+        </p:txBody>
+      </p:sp>
+    </p:spTree>
+    <p:extLst>
+      <p:ext uri="{BB962C8B-B14F-4D97-AF65-F5344CB8AC3E}">
+        <p14:creationId xmlns:p14="http://schemas.microsoft.com/office/powerpoint/2010/main" val="1024086991"/>
+      </p:ext>
+    </p:extLst>
+  </p:cSld>
+  <p:clrMapOvr>
+    <a:masterClrMapping/>
+  </p:clrMapOvr>
+</p:notes>
+</file>
+
+<file path=ppt/notesSlides/notesSlide16.xml><?xml version="1.0" encoding="utf-8"?>
+<p:notes xmlns:a="http://schemas.openxmlformats.org/drawingml/2006/main" xmlns:r="http://schemas.openxmlformats.org/officeDocument/2006/relationships" xmlns:p="http://schemas.openxmlformats.org/presentationml/2006/main">
+  <p:cSld>
+    <p:spTree>
+      <p:nvGrpSpPr>
+        <p:cNvPr id="1" name=""/>
+        <p:cNvGrpSpPr/>
+        <p:nvPr/>
+      </p:nvGrpSpPr>
+      <p:grpSpPr>
+        <a:xfrm>
+          <a:off x="0" y="0"/>
+          <a:ext cx="0" cy="0"/>
+          <a:chOff x="0" y="0"/>
+          <a:chExt cx="0" cy="0"/>
+        </a:xfrm>
+      </p:grpSpPr>
+      <p:sp>
+        <p:nvSpPr>
+          <p:cNvPr id="2" name="Slide Image Placeholder 1"/>
+          <p:cNvSpPr>
+            <a:spLocks noGrp="1" noRot="1" noChangeAspect="1"/>
+          </p:cNvSpPr>
+          <p:nvPr>
+            <p:ph type="sldImg"/>
+          </p:nvPr>
+        </p:nvSpPr>
+        <p:spPr/>
+      </p:sp>
+      <p:sp>
+        <p:nvSpPr>
+          <p:cNvPr id="3" name="Notes Placeholder 2"/>
+          <p:cNvSpPr>
+            <a:spLocks noGrp="1"/>
+          </p:cNvSpPr>
+          <p:nvPr>
+            <p:ph type="body" idx="1"/>
+          </p:nvPr>
+        </p:nvSpPr>
+        <p:spPr/>
+        <p:txBody>
+          <a:bodyPr/>
+          <a:lstStyle/>
+          <a:p>
+            <a:r>
+              <a:rPr lang="en-US" dirty="0"/>
               <a:t>【出典】
 要約：公的統計と原典を明記する。未確認のものは未確認と言う
 出典一覧です。確認が必要なものには印を付けています。発表前に原典を確認してください。</a:t>
@@ -1081,7 +1172,7 @@
           <a:p>
             <a:fld id="{F7021451-1387-4CA6-816F-3879F97B5CBC}" type="slidenum">
               <a:rPr lang="en-US"/>
-              <a:t>15</a:t>
+              <a:t>16</a:t>
             </a:fld>
             <a:endParaRPr lang="en-US"/>
           </a:p>
@@ -3110,7 +3201,7 @@
                 <a:ea typeface="Meiryo" pitchFamily="34" charset="-122"/>
                 <a:cs typeface="Meiryo" pitchFamily="34" charset="-120"/>
               </a:rPr>
-              <a:t>根拠11〜13</a:t>
+              <a:t>根拠11〜14</a:t>
             </a:r>
             <a:endParaRPr lang="en-US" sz="1050" dirty="0"/>
           </a:p>
@@ -3152,7 +3243,7 @@
                 <a:ea typeface="Meiryo" pitchFamily="34" charset="-122"/>
                 <a:cs typeface="Meiryo" pitchFamily="34" charset="-120"/>
               </a:rPr>
-              <a:t>市場規模・最初の顧客・厳しい質問</a:t>
+              <a:t>市場・最初の顧客・端末・厳しい質問</a:t>
             </a:r>
             <a:endParaRPr lang="en-US" sz="1050" dirty="0"/>
           </a:p>
@@ -15495,7 +15586,7 @@
                 <a:ea typeface="Meiryo" pitchFamily="34" charset="-122"/>
                 <a:cs typeface="Meiryo" pitchFamily="34" charset="-120"/>
               </a:rPr>
-              <a:t>厳しい質問 ─ 数字 → 式 → 前提の順で答える</a:t>
+              <a:t>端末と実証 ─ グラスは作らず選び、効果は実測する</a:t>
             </a:r>
             <a:endParaRPr lang="en-US" sz="2000" dirty="0"/>
           </a:p>
@@ -15537,7 +15628,7 @@
                 <a:ea typeface="Meiryo" pitchFamily="34" charset="-122"/>
                 <a:cs typeface="Meiryo" pitchFamily="34" charset="-120"/>
               </a:rPr>
-              <a:t>一言で答え、根拠のページを示す</a:t>
+              <a:t>端末の条件と候補（公表値）、手元ARの実証の設計</a:t>
             </a:r>
             <a:endParaRPr lang="en-US" sz="1200" dirty="0"/>
           </a:p>
@@ -15545,7 +15636,7 @@
       </p:sp>
       <p:graphicFrame>
         <p:nvGraphicFramePr>
-          <p:cNvPr id="15" name="qa"/>
+          <p:cNvPr id="15" name="device-spec"/>
           <p:cNvGraphicFramePr>
             <a:graphicFrameLocks noGrp="1"/>
           </p:cNvGraphicFramePr>
@@ -15558,17 +15649,17 @@
           </p:nvPr>
         </p:nvGraphicFramePr>
         <p:xfrm>
-          <a:off x="365760" y="1024128"/>
-          <a:ext cx="8412480" cy="914400"/>
+          <a:off x="365760" y="1051560"/>
+          <a:ext cx="4846320" cy="914400"/>
         </p:xfrm>
         <a:graphic>
           <a:graphicData uri="http://schemas.openxmlformats.org/drawingml/2006/table">
             <a:tbl>
               <a:tblPr/>
               <a:tblGrid>
-                <a:gridCol w="1920240"/>
-                <a:gridCol w="5394960"/>
-                <a:gridCol w="1097280"/>
+                <a:gridCol w="1143000"/>
+                <a:gridCol w="1005840"/>
+                <a:gridCol w="2697480"/>
               </a:tblGrid>
               <a:tr h="274320">
                 <a:tc>
@@ -15588,7 +15679,7 @@
                           <a:ea typeface="Meiryo" pitchFamily="34" charset="-122"/>
                           <a:cs typeface="Meiryo" pitchFamily="34" charset="-120"/>
                         </a:rPr>
-                        <a:t>質問</a:t>
+                        <a:t>現場の条件</a:t>
                       </a:r>
                       <a:endParaRPr lang="en-US" sz="850" dirty="0">
                         <a:latin typeface="Meiryo" charset="0"/>
@@ -15638,7 +15729,7 @@
                           <a:ea typeface="Meiryo" pitchFamily="34" charset="-122"/>
                           <a:cs typeface="Meiryo" pitchFamily="34" charset="-120"/>
                         </a:rPr>
-                        <a:t>一言の答え</a:t>
+                        <a:t>目安</a:t>
                       </a:r>
                       <a:endParaRPr lang="en-US" sz="850" dirty="0">
                         <a:latin typeface="Meiryo" charset="0"/>
@@ -15676,7 +15767,7 @@
                     <a:bodyPr/>
                     <a:lstStyle/>
                     <a:p>
-                      <a:pPr algn="ctr" indent="0" marL="0">
+                      <a:pPr algn="l" indent="0" marL="0">
                         <a:buNone/>
                       </a:pPr>
                       <a:r>
@@ -15688,7 +15779,7 @@
                           <a:ea typeface="Meiryo" pitchFamily="34" charset="-122"/>
                           <a:cs typeface="Meiryo" pitchFamily="34" charset="-120"/>
                         </a:rPr>
-                        <a:t>根拠</a:t>
+                        <a:t>候補の公表値（RealWear Navigator 520）</a:t>
                       </a:r>
                       <a:endParaRPr lang="en-US" sz="850" dirty="0">
                         <a:latin typeface="Meiryo" charset="0"/>
@@ -15740,7 +15831,7 @@
                           <a:ea typeface="Meiryo" pitchFamily="34" charset="-122"/>
                           <a:cs typeface="Meiryo" pitchFamily="34" charset="-120"/>
                         </a:rPr>
-                        <a:t>本当に年300万円払う？</a:t>
+                        <a:t>落下</a:t>
                       </a:r>
                       <a:endParaRPr lang="en-US" sz="850" dirty="0">
                         <a:latin typeface="Meiryo" charset="0"/>
@@ -15790,7 +15881,7 @@
                           <a:ea typeface="Meiryo" pitchFamily="34" charset="-122"/>
                           <a:cs typeface="Meiryo" pitchFamily="34" charset="-120"/>
                         </a:rPr>
-                        <a:t>月240万円分の時間が浮き、約2か月で元が取れます</a:t>
+                        <a:t>2m級</a:t>
                       </a:r>
                       <a:endParaRPr lang="en-US" sz="850" dirty="0">
                         <a:latin typeface="Meiryo" charset="0"/>
@@ -15828,7 +15919,7 @@
                     <a:bodyPr/>
                     <a:lstStyle/>
                     <a:p>
-                      <a:pPr algn="ctr" indent="0" marL="0">
+                      <a:pPr algn="l" indent="0" marL="0">
                         <a:buNone/>
                       </a:pPr>
                       <a:r>
@@ -15840,7 +15931,7 @@
                           <a:ea typeface="Meiryo" pitchFamily="34" charset="-122"/>
                           <a:cs typeface="Meiryo" pitchFamily="34" charset="-120"/>
                         </a:rPr>
-                        <a:t>根拠3・4</a:t>
+                        <a:t>2mの落下試験（販売店の公表値）</a:t>
                       </a:r>
                       <a:endParaRPr lang="en-US" sz="850" dirty="0">
                         <a:latin typeface="Meiryo" charset="0"/>
@@ -15892,7 +15983,7 @@
                           <a:ea typeface="Meiryo" pitchFamily="34" charset="-122"/>
                           <a:cs typeface="Meiryo" pitchFamily="34" charset="-120"/>
                         </a:rPr>
-                        <a:t>月6時間は本当？</a:t>
+                        <a:t>防じん・防水</a:t>
                       </a:r>
                       <a:endParaRPr lang="en-US" sz="850" dirty="0">
                         <a:latin typeface="Meiryo" charset="0"/>
@@ -15942,7 +16033,7 @@
                           <a:ea typeface="Meiryo" pitchFamily="34" charset="-122"/>
                           <a:cs typeface="Meiryo" pitchFamily="34" charset="-120"/>
                         </a:rPr>
-                        <a:t>建設業の実績を準用した仮説です。500万円の実証で実測します</a:t>
+                        <a:t>IP66級</a:t>
                       </a:r>
                       <a:endParaRPr lang="en-US" sz="850" dirty="0">
                         <a:latin typeface="Meiryo" charset="0"/>
@@ -15980,7 +16071,7 @@
                     <a:bodyPr/>
                     <a:lstStyle/>
                     <a:p>
-                      <a:pPr algn="ctr" indent="0" marL="0">
+                      <a:pPr algn="l" indent="0" marL="0">
                         <a:buNone/>
                       </a:pPr>
                       <a:r>
@@ -15992,7 +16083,7 @@
                           <a:ea typeface="Meiryo" pitchFamily="34" charset="-122"/>
                           <a:cs typeface="Meiryo" pitchFamily="34" charset="-120"/>
                         </a:rPr>
-                        <a:t>根拠2</a:t>
+                        <a:t>IP66</a:t>
                       </a:r>
                       <a:endParaRPr lang="en-US" sz="850" dirty="0">
                         <a:latin typeface="Meiryo" charset="0"/>
@@ -16044,7 +16135,7 @@
                           <a:ea typeface="Meiryo" pitchFamily="34" charset="-122"/>
                           <a:cs typeface="Meiryo" pitchFamily="34" charset="-120"/>
                         </a:rPr>
-                        <a:t>なぜ電気工事から？</a:t>
+                        <a:t>電池</a:t>
                       </a:r>
                       <a:endParaRPr lang="en-US" sz="850" dirty="0">
                         <a:latin typeface="Meiryo" charset="0"/>
@@ -16094,7 +16185,7 @@
                           <a:ea typeface="Meiryo" pitchFamily="34" charset="-122"/>
                           <a:cs typeface="Meiryo" pitchFamily="34" charset="-120"/>
                         </a:rPr>
-                        <a:t>市場が最も大きく、残業規制で困りごとが強く、私の経歴が信用になるからです</a:t>
+                        <a:t>1シフト</a:t>
                       </a:r>
                       <a:endParaRPr lang="en-US" sz="850" dirty="0">
                         <a:latin typeface="Meiryo" charset="0"/>
@@ -16132,7 +16223,7 @@
                     <a:bodyPr/>
                     <a:lstStyle/>
                     <a:p>
-                      <a:pPr algn="ctr" indent="0" marL="0">
+                      <a:pPr algn="l" indent="0" marL="0">
                         <a:buNone/>
                       </a:pPr>
                       <a:r>
@@ -16144,7 +16235,7 @@
                           <a:ea typeface="Meiryo" pitchFamily="34" charset="-122"/>
                           <a:cs typeface="Meiryo" pitchFamily="34" charset="-120"/>
                         </a:rPr>
-                        <a:t>根拠12</a:t>
+                        <a:t>約6〜8時間、動作中に交換できる</a:t>
                       </a:r>
                       <a:endParaRPr lang="en-US" sz="850" dirty="0">
                         <a:latin typeface="Meiryo" charset="0"/>
@@ -16196,7 +16287,7 @@
                           <a:ea typeface="Meiryo" pitchFamily="34" charset="-122"/>
                           <a:cs typeface="Meiryo" pitchFamily="34" charset="-120"/>
                         </a:rPr>
-                        <a:t>ANDPADがあるのでは？</a:t>
+                        <a:t>装着</a:t>
                       </a:r>
                       <a:endParaRPr lang="en-US" sz="850" dirty="0">
                         <a:latin typeface="Meiryo" charset="0"/>
@@ -16246,7 +16337,7 @@
                           <a:ea typeface="Meiryo" pitchFamily="34" charset="-122"/>
                           <a:cs typeface="Meiryo" pitchFamily="34" charset="-120"/>
                         </a:rPr>
-                        <a:t>あれは人が入力する器。当社は自動で記録し判断を渡す。競わず連携します</a:t>
+                        <a:t>ヘルメット</a:t>
                       </a:r>
                       <a:endParaRPr lang="en-US" sz="850" dirty="0">
                         <a:latin typeface="Meiryo" charset="0"/>
@@ -16284,7 +16375,7 @@
                     <a:bodyPr/>
                     <a:lstStyle/>
                     <a:p>
-                      <a:pPr algn="ctr" indent="0" marL="0">
+                      <a:pPr algn="l" indent="0" marL="0">
                         <a:buNone/>
                       </a:pPr>
                       <a:r>
@@ -16296,7 +16387,7 @@
                           <a:ea typeface="Meiryo" pitchFamily="34" charset="-122"/>
                           <a:cs typeface="Meiryo" pitchFamily="34" charset="-120"/>
                         </a:rPr>
-                        <a:t>発表資料③</a:t>
+                        <a:t>ヘルメット用クリップ（別売）</a:t>
                       </a:r>
                       <a:endParaRPr lang="en-US" sz="850" dirty="0">
                         <a:latin typeface="Meiryo" charset="0"/>
@@ -16348,7 +16439,7 @@
                           <a:ea typeface="Meiryo" pitchFamily="34" charset="-122"/>
                           <a:cs typeface="Meiryo" pitchFamily="34" charset="-120"/>
                         </a:rPr>
-                        <a:t>なぜ4年目まで赤字？</a:t>
+                        <a:t>操作</a:t>
                       </a:r>
                       <a:endParaRPr lang="en-US" sz="850" dirty="0">
                         <a:latin typeface="Meiryo" charset="0"/>
@@ -16398,7 +16489,7 @@
                           <a:ea typeface="Meiryo" pitchFamily="34" charset="-122"/>
                           <a:cs typeface="Meiryo" pitchFamily="34" charset="-120"/>
                         </a:rPr>
-                        <a:t>人を先に雇うからです。1人2.8拠点を超える4年目に黒字</a:t>
+                        <a:t>手袋のまま</a:t>
                       </a:r>
                       <a:endParaRPr lang="en-US" sz="850" dirty="0">
                         <a:latin typeface="Meiryo" charset="0"/>
@@ -16436,7 +16527,7 @@
                     <a:bodyPr/>
                     <a:lstStyle/>
                     <a:p>
-                      <a:pPr algn="ctr" indent="0" marL="0">
+                      <a:pPr algn="l" indent="0" marL="0">
                         <a:buNone/>
                       </a:pPr>
                       <a:r>
@@ -16448,7 +16539,7 @@
                           <a:ea typeface="Meiryo" pitchFamily="34" charset="-122"/>
                           <a:cs typeface="Meiryo" pitchFamily="34" charset="-120"/>
                         </a:rPr>
-                        <a:t>根拠7</a:t>
+                        <a:t>音声操作</a:t>
                       </a:r>
                       <a:endParaRPr lang="en-US" sz="850" dirty="0">
                         <a:latin typeface="Meiryo" charset="0"/>
@@ -16500,7 +16591,7 @@
                           <a:ea typeface="Meiryo" pitchFamily="34" charset="-122"/>
                           <a:cs typeface="Meiryo" pitchFamily="34" charset="-120"/>
                         </a:rPr>
-                        <a:t>獲得が遅れたら？</a:t>
+                        <a:t>温度</a:t>
                       </a:r>
                       <a:endParaRPr lang="en-US" sz="850" dirty="0">
                         <a:latin typeface="Meiryo" charset="0"/>
@@ -16550,7 +16641,7 @@
                           <a:ea typeface="Meiryo" pitchFamily="34" charset="-122"/>
                           <a:cs typeface="Meiryo" pitchFamily="34" charset="-120"/>
                         </a:rPr>
-                        <a:t>採用も遅らせます。3割遅れても現金は2,000万円を割りません</a:t>
+                        <a:t>屋外の夏冬</a:t>
                       </a:r>
                       <a:endParaRPr lang="en-US" sz="850" dirty="0">
                         <a:latin typeface="Meiryo" charset="0"/>
@@ -16588,7 +16679,7 @@
                     <a:bodyPr/>
                     <a:lstStyle/>
                     <a:p>
-                      <a:pPr algn="ctr" indent="0" marL="0">
+                      <a:pPr algn="l" indent="0" marL="0">
                         <a:buNone/>
                       </a:pPr>
                       <a:r>
@@ -16600,767 +16691,7 @@
                           <a:ea typeface="Meiryo" pitchFamily="34" charset="-122"/>
                           <a:cs typeface="Meiryo" pitchFamily="34" charset="-120"/>
                         </a:rPr>
-                        <a:t>根拠9</a:t>
-                      </a:r>
-                      <a:endParaRPr lang="en-US" sz="850" dirty="0">
-                        <a:latin typeface="Meiryo" charset="0"/>
-                        <a:ea typeface="Meiryo" charset="0"/>
-                        <a:cs typeface="Meiryo" charset="0"/>
-                      </a:endParaRPr>
-                    </a:p>
-                  </a:txBody>
-                  <a:tcPr marL="54864" marR="54864" marT="18288" marB="18288" anchor="ctr">
-                    <a:lnL w="0" cap="flat" cmpd="sng" algn="ctr">
-                      <a:noFill/>
-                    </a:lnL>
-                    <a:lnR w="0" cap="flat" cmpd="sng" algn="ctr">
-                      <a:noFill/>
-                    </a:lnR>
-                    <a:lnT w="0" cap="flat" cmpd="sng" algn="ctr">
-                      <a:noFill/>
-                    </a:lnT>
-                    <a:lnB w="9525" cap="flat" cmpd="sng" algn="ctr">
-                      <a:solidFill>
-                        <a:srgbClr val="BFBFBF"/>
-                      </a:solidFill>
-                      <a:prstDash val="solid"/>
-                      <a:round/>
-                      <a:headEnd type="none" w="med" len="med"/>
-                      <a:tailEnd type="none" w="med" len="med"/>
-                    </a:lnB>
-                    <a:solidFill>
-                      <a:srgbClr val="FFFFFF"/>
-                    </a:solidFill>
-                  </a:tcPr>
-                </a:tc>
-              </a:tr>
-              <a:tr h="274320">
-                <a:tc>
-                  <a:txBody>
-                    <a:bodyPr/>
-                    <a:lstStyle/>
-                    <a:p>
-                      <a:pPr algn="l" indent="0" marL="0">
-                        <a:buNone/>
-                      </a:pPr>
-                      <a:r>
-                        <a:rPr lang="en-US" sz="850" dirty="0">
-                          <a:solidFill>
-                            <a:srgbClr val="1A1A1A"/>
-                          </a:solidFill>
-                          <a:latin typeface="Meiryo" pitchFamily="34" charset="0"/>
-                          <a:ea typeface="Meiryo" pitchFamily="34" charset="-122"/>
-                          <a:cs typeface="Meiryo" pitchFamily="34" charset="-120"/>
-                        </a:rPr>
-                        <a:t>値引きされたら？</a:t>
-                      </a:r>
-                      <a:endParaRPr lang="en-US" sz="850" dirty="0">
-                        <a:latin typeface="Meiryo" charset="0"/>
-                        <a:ea typeface="Meiryo" charset="0"/>
-                        <a:cs typeface="Meiryo" charset="0"/>
-                      </a:endParaRPr>
-                    </a:p>
-                  </a:txBody>
-                  <a:tcPr marL="54864" marR="54864" marT="18288" marB="18288" anchor="ctr">
-                    <a:lnL w="0" cap="flat" cmpd="sng" algn="ctr">
-                      <a:noFill/>
-                    </a:lnL>
-                    <a:lnR w="0" cap="flat" cmpd="sng" algn="ctr">
-                      <a:noFill/>
-                    </a:lnR>
-                    <a:lnT w="0" cap="flat" cmpd="sng" algn="ctr">
-                      <a:noFill/>
-                    </a:lnT>
-                    <a:lnB w="9525" cap="flat" cmpd="sng" algn="ctr">
-                      <a:solidFill>
-                        <a:srgbClr val="BFBFBF"/>
-                      </a:solidFill>
-                      <a:prstDash val="solid"/>
-                      <a:round/>
-                      <a:headEnd type="none" w="med" len="med"/>
-                      <a:tailEnd type="none" w="med" len="med"/>
-                    </a:lnB>
-                    <a:solidFill>
-                      <a:srgbClr val="FFFFFF"/>
-                    </a:solidFill>
-                  </a:tcPr>
-                </a:tc>
-                <a:tc>
-                  <a:txBody>
-                    <a:bodyPr/>
-                    <a:lstStyle/>
-                    <a:p>
-                      <a:pPr algn="l" indent="0" marL="0">
-                        <a:buNone/>
-                      </a:pPr>
-                      <a:r>
-                        <a:rPr lang="en-US" sz="850" dirty="0">
-                          <a:solidFill>
-                            <a:srgbClr val="1A1A1A"/>
-                          </a:solidFill>
-                          <a:latin typeface="Meiryo" pitchFamily="34" charset="0"/>
-                          <a:ea typeface="Meiryo" pitchFamily="34" charset="-122"/>
-                          <a:cs typeface="Meiryo" pitchFamily="34" charset="-120"/>
-                        </a:rPr>
-                        <a:t>2割引きでも4年目に黒字。5年目の営業利益は3,200万円</a:t>
-                      </a:r>
-                      <a:endParaRPr lang="en-US" sz="850" dirty="0">
-                        <a:latin typeface="Meiryo" charset="0"/>
-                        <a:ea typeface="Meiryo" charset="0"/>
-                        <a:cs typeface="Meiryo" charset="0"/>
-                      </a:endParaRPr>
-                    </a:p>
-                  </a:txBody>
-                  <a:tcPr marL="54864" marR="54864" marT="18288" marB="18288" anchor="ctr">
-                    <a:lnL w="0" cap="flat" cmpd="sng" algn="ctr">
-                      <a:noFill/>
-                    </a:lnL>
-                    <a:lnR w="0" cap="flat" cmpd="sng" algn="ctr">
-                      <a:noFill/>
-                    </a:lnR>
-                    <a:lnT w="0" cap="flat" cmpd="sng" algn="ctr">
-                      <a:noFill/>
-                    </a:lnT>
-                    <a:lnB w="9525" cap="flat" cmpd="sng" algn="ctr">
-                      <a:solidFill>
-                        <a:srgbClr val="BFBFBF"/>
-                      </a:solidFill>
-                      <a:prstDash val="solid"/>
-                      <a:round/>
-                      <a:headEnd type="none" w="med" len="med"/>
-                      <a:tailEnd type="none" w="med" len="med"/>
-                    </a:lnB>
-                    <a:solidFill>
-                      <a:srgbClr val="FFFFFF"/>
-                    </a:solidFill>
-                  </a:tcPr>
-                </a:tc>
-                <a:tc>
-                  <a:txBody>
-                    <a:bodyPr/>
-                    <a:lstStyle/>
-                    <a:p>
-                      <a:pPr algn="ctr" indent="0" marL="0">
-                        <a:buNone/>
-                      </a:pPr>
-                      <a:r>
-                        <a:rPr lang="en-US" sz="850" dirty="0">
-                          <a:solidFill>
-                            <a:srgbClr val="1A1A1A"/>
-                          </a:solidFill>
-                          <a:latin typeface="Meiryo" pitchFamily="34" charset="0"/>
-                          <a:ea typeface="Meiryo" pitchFamily="34" charset="-122"/>
-                          <a:cs typeface="Meiryo" pitchFamily="34" charset="-120"/>
-                        </a:rPr>
-                        <a:t>根拠9</a:t>
-                      </a:r>
-                      <a:endParaRPr lang="en-US" sz="850" dirty="0">
-                        <a:latin typeface="Meiryo" charset="0"/>
-                        <a:ea typeface="Meiryo" charset="0"/>
-                        <a:cs typeface="Meiryo" charset="0"/>
-                      </a:endParaRPr>
-                    </a:p>
-                  </a:txBody>
-                  <a:tcPr marL="54864" marR="54864" marT="18288" marB="18288" anchor="ctr">
-                    <a:lnL w="0" cap="flat" cmpd="sng" algn="ctr">
-                      <a:noFill/>
-                    </a:lnL>
-                    <a:lnR w="0" cap="flat" cmpd="sng" algn="ctr">
-                      <a:noFill/>
-                    </a:lnR>
-                    <a:lnT w="0" cap="flat" cmpd="sng" algn="ctr">
-                      <a:noFill/>
-                    </a:lnT>
-                    <a:lnB w="9525" cap="flat" cmpd="sng" algn="ctr">
-                      <a:solidFill>
-                        <a:srgbClr val="BFBFBF"/>
-                      </a:solidFill>
-                      <a:prstDash val="solid"/>
-                      <a:round/>
-                      <a:headEnd type="none" w="med" len="med"/>
-                      <a:tailEnd type="none" w="med" len="med"/>
-                    </a:lnB>
-                    <a:solidFill>
-                      <a:srgbClr val="FFFFFF"/>
-                    </a:solidFill>
-                  </a:tcPr>
-                </a:tc>
-              </a:tr>
-              <a:tr h="274320">
-                <a:tc>
-                  <a:txBody>
-                    <a:bodyPr/>
-                    <a:lstStyle/>
-                    <a:p>
-                      <a:pPr algn="l" indent="0" marL="0">
-                        <a:buNone/>
-                      </a:pPr>
-                      <a:r>
-                        <a:rPr lang="en-US" sz="850" dirty="0">
-                          <a:solidFill>
-                            <a:srgbClr val="1A1A1A"/>
-                          </a:solidFill>
-                          <a:latin typeface="Meiryo" pitchFamily="34" charset="0"/>
-                          <a:ea typeface="Meiryo" pitchFamily="34" charset="-122"/>
-                          <a:cs typeface="Meiryo" pitchFamily="34" charset="-120"/>
-                        </a:rPr>
-                        <a:t>LTV 7年は甘くない？</a:t>
-                      </a:r>
-                      <a:endParaRPr lang="en-US" sz="850" dirty="0">
-                        <a:latin typeface="Meiryo" charset="0"/>
-                        <a:ea typeface="Meiryo" charset="0"/>
-                        <a:cs typeface="Meiryo" charset="0"/>
-                      </a:endParaRPr>
-                    </a:p>
-                  </a:txBody>
-                  <a:tcPr marL="54864" marR="54864" marT="18288" marB="18288" anchor="ctr">
-                    <a:lnL w="0" cap="flat" cmpd="sng" algn="ctr">
-                      <a:noFill/>
-                    </a:lnL>
-                    <a:lnR w="0" cap="flat" cmpd="sng" algn="ctr">
-                      <a:noFill/>
-                    </a:lnR>
-                    <a:lnT w="0" cap="flat" cmpd="sng" algn="ctr">
-                      <a:noFill/>
-                    </a:lnT>
-                    <a:lnB w="9525" cap="flat" cmpd="sng" algn="ctr">
-                      <a:solidFill>
-                        <a:srgbClr val="BFBFBF"/>
-                      </a:solidFill>
-                      <a:prstDash val="solid"/>
-                      <a:round/>
-                      <a:headEnd type="none" w="med" len="med"/>
-                      <a:tailEnd type="none" w="med" len="med"/>
-                    </a:lnB>
-                    <a:solidFill>
-                      <a:srgbClr val="FFFFFF"/>
-                    </a:solidFill>
-                  </a:tcPr>
-                </a:tc>
-                <a:tc>
-                  <a:txBody>
-                    <a:bodyPr/>
-                    <a:lstStyle/>
-                    <a:p>
-                      <a:pPr algn="l" indent="0" marL="0">
-                        <a:buNone/>
-                      </a:pPr>
-                      <a:r>
-                        <a:rPr lang="en-US" sz="850" dirty="0">
-                          <a:solidFill>
-                            <a:srgbClr val="1A1A1A"/>
-                          </a:solidFill>
-                          <a:latin typeface="Meiryo" pitchFamily="34" charset="0"/>
-                          <a:ea typeface="Meiryo" pitchFamily="34" charset="-122"/>
-                          <a:cs typeface="Meiryo" pitchFamily="34" charset="-120"/>
-                        </a:rPr>
-                        <a:t>計画の解約率なら平均18年。3年でもCACの13倍です</a:t>
-                      </a:r>
-                      <a:endParaRPr lang="en-US" sz="850" dirty="0">
-                        <a:latin typeface="Meiryo" charset="0"/>
-                        <a:ea typeface="Meiryo" charset="0"/>
-                        <a:cs typeface="Meiryo" charset="0"/>
-                      </a:endParaRPr>
-                    </a:p>
-                  </a:txBody>
-                  <a:tcPr marL="54864" marR="54864" marT="18288" marB="18288" anchor="ctr">
-                    <a:lnL w="0" cap="flat" cmpd="sng" algn="ctr">
-                      <a:noFill/>
-                    </a:lnL>
-                    <a:lnR w="0" cap="flat" cmpd="sng" algn="ctr">
-                      <a:noFill/>
-                    </a:lnR>
-                    <a:lnT w="0" cap="flat" cmpd="sng" algn="ctr">
-                      <a:noFill/>
-                    </a:lnT>
-                    <a:lnB w="9525" cap="flat" cmpd="sng" algn="ctr">
-                      <a:solidFill>
-                        <a:srgbClr val="BFBFBF"/>
-                      </a:solidFill>
-                      <a:prstDash val="solid"/>
-                      <a:round/>
-                      <a:headEnd type="none" w="med" len="med"/>
-                      <a:tailEnd type="none" w="med" len="med"/>
-                    </a:lnB>
-                    <a:solidFill>
-                      <a:srgbClr val="FFFFFF"/>
-                    </a:solidFill>
-                  </a:tcPr>
-                </a:tc>
-                <a:tc>
-                  <a:txBody>
-                    <a:bodyPr/>
-                    <a:lstStyle/>
-                    <a:p>
-                      <a:pPr algn="ctr" indent="0" marL="0">
-                        <a:buNone/>
-                      </a:pPr>
-                      <a:r>
-                        <a:rPr lang="en-US" sz="850" dirty="0">
-                          <a:solidFill>
-                            <a:srgbClr val="1A1A1A"/>
-                          </a:solidFill>
-                          <a:latin typeface="Meiryo" pitchFamily="34" charset="0"/>
-                          <a:ea typeface="Meiryo" pitchFamily="34" charset="-122"/>
-                          <a:cs typeface="Meiryo" pitchFamily="34" charset="-120"/>
-                        </a:rPr>
-                        <a:t>根拠8</a:t>
-                      </a:r>
-                      <a:endParaRPr lang="en-US" sz="850" dirty="0">
-                        <a:latin typeface="Meiryo" charset="0"/>
-                        <a:ea typeface="Meiryo" charset="0"/>
-                        <a:cs typeface="Meiryo" charset="0"/>
-                      </a:endParaRPr>
-                    </a:p>
-                  </a:txBody>
-                  <a:tcPr marL="54864" marR="54864" marT="18288" marB="18288" anchor="ctr">
-                    <a:lnL w="0" cap="flat" cmpd="sng" algn="ctr">
-                      <a:noFill/>
-                    </a:lnL>
-                    <a:lnR w="0" cap="flat" cmpd="sng" algn="ctr">
-                      <a:noFill/>
-                    </a:lnR>
-                    <a:lnT w="0" cap="flat" cmpd="sng" algn="ctr">
-                      <a:noFill/>
-                    </a:lnT>
-                    <a:lnB w="9525" cap="flat" cmpd="sng" algn="ctr">
-                      <a:solidFill>
-                        <a:srgbClr val="BFBFBF"/>
-                      </a:solidFill>
-                      <a:prstDash val="solid"/>
-                      <a:round/>
-                      <a:headEnd type="none" w="med" len="med"/>
-                      <a:tailEnd type="none" w="med" len="med"/>
-                    </a:lnB>
-                    <a:solidFill>
-                      <a:srgbClr val="FFFFFF"/>
-                    </a:solidFill>
-                  </a:tcPr>
-                </a:tc>
-              </a:tr>
-              <a:tr h="274320">
-                <a:tc>
-                  <a:txBody>
-                    <a:bodyPr/>
-                    <a:lstStyle/>
-                    <a:p>
-                      <a:pPr algn="l" indent="0" marL="0">
-                        <a:buNone/>
-                      </a:pPr>
-                      <a:r>
-                        <a:rPr lang="en-US" sz="850" dirty="0">
-                          <a:solidFill>
-                            <a:srgbClr val="1A1A1A"/>
-                          </a:solidFill>
-                          <a:latin typeface="Meiryo" pitchFamily="34" charset="0"/>
-                          <a:ea typeface="Meiryo" pitchFamily="34" charset="-122"/>
-                          <a:cs typeface="Meiryo" pitchFamily="34" charset="-120"/>
-                        </a:rPr>
-                        <a:t>1.5億円は多すぎない？</a:t>
-                      </a:r>
-                      <a:endParaRPr lang="en-US" sz="850" dirty="0">
-                        <a:latin typeface="Meiryo" charset="0"/>
-                        <a:ea typeface="Meiryo" charset="0"/>
-                        <a:cs typeface="Meiryo" charset="0"/>
-                      </a:endParaRPr>
-                    </a:p>
-                  </a:txBody>
-                  <a:tcPr marL="54864" marR="54864" marT="18288" marB="18288" anchor="ctr">
-                    <a:lnL w="0" cap="flat" cmpd="sng" algn="ctr">
-                      <a:noFill/>
-                    </a:lnL>
-                    <a:lnR w="0" cap="flat" cmpd="sng" algn="ctr">
-                      <a:noFill/>
-                    </a:lnR>
-                    <a:lnT w="0" cap="flat" cmpd="sng" algn="ctr">
-                      <a:noFill/>
-                    </a:lnT>
-                    <a:lnB w="9525" cap="flat" cmpd="sng" algn="ctr">
-                      <a:solidFill>
-                        <a:srgbClr val="BFBFBF"/>
-                      </a:solidFill>
-                      <a:prstDash val="solid"/>
-                      <a:round/>
-                      <a:headEnd type="none" w="med" len="med"/>
-                      <a:tailEnd type="none" w="med" len="med"/>
-                    </a:lnB>
-                    <a:solidFill>
-                      <a:srgbClr val="FFFFFF"/>
-                    </a:solidFill>
-                  </a:tcPr>
-                </a:tc>
-                <a:tc>
-                  <a:txBody>
-                    <a:bodyPr/>
-                    <a:lstStyle/>
-                    <a:p>
-                      <a:pPr algn="l" indent="0" marL="0">
-                        <a:buNone/>
-                      </a:pPr>
-                      <a:r>
-                        <a:rPr lang="en-US" sz="850" dirty="0">
-                          <a:solidFill>
-                            <a:srgbClr val="1A1A1A"/>
-                          </a:solidFill>
-                          <a:latin typeface="Meiryo" pitchFamily="34" charset="0"/>
-                          <a:ea typeface="Meiryo" pitchFamily="34" charset="-122"/>
-                          <a:cs typeface="Meiryo" pitchFamily="34" charset="-120"/>
-                        </a:rPr>
-                        <a:t>赤字のピーク・運転資金・1年遅れの備えを積んだ額です</a:t>
-                      </a:r>
-                      <a:endParaRPr lang="en-US" sz="850" dirty="0">
-                        <a:latin typeface="Meiryo" charset="0"/>
-                        <a:ea typeface="Meiryo" charset="0"/>
-                        <a:cs typeface="Meiryo" charset="0"/>
-                      </a:endParaRPr>
-                    </a:p>
-                  </a:txBody>
-                  <a:tcPr marL="54864" marR="54864" marT="18288" marB="18288" anchor="ctr">
-                    <a:lnL w="0" cap="flat" cmpd="sng" algn="ctr">
-                      <a:noFill/>
-                    </a:lnL>
-                    <a:lnR w="0" cap="flat" cmpd="sng" algn="ctr">
-                      <a:noFill/>
-                    </a:lnR>
-                    <a:lnT w="0" cap="flat" cmpd="sng" algn="ctr">
-                      <a:noFill/>
-                    </a:lnT>
-                    <a:lnB w="9525" cap="flat" cmpd="sng" algn="ctr">
-                      <a:solidFill>
-                        <a:srgbClr val="BFBFBF"/>
-                      </a:solidFill>
-                      <a:prstDash val="solid"/>
-                      <a:round/>
-                      <a:headEnd type="none" w="med" len="med"/>
-                      <a:tailEnd type="none" w="med" len="med"/>
-                    </a:lnB>
-                    <a:solidFill>
-                      <a:srgbClr val="FFFFFF"/>
-                    </a:solidFill>
-                  </a:tcPr>
-                </a:tc>
-                <a:tc>
-                  <a:txBody>
-                    <a:bodyPr/>
-                    <a:lstStyle/>
-                    <a:p>
-                      <a:pPr algn="ctr" indent="0" marL="0">
-                        <a:buNone/>
-                      </a:pPr>
-                      <a:r>
-                        <a:rPr lang="en-US" sz="850" dirty="0">
-                          <a:solidFill>
-                            <a:srgbClr val="1A1A1A"/>
-                          </a:solidFill>
-                          <a:latin typeface="Meiryo" pitchFamily="34" charset="0"/>
-                          <a:ea typeface="Meiryo" pitchFamily="34" charset="-122"/>
-                          <a:cs typeface="Meiryo" pitchFamily="34" charset="-120"/>
-                        </a:rPr>
-                        <a:t>根拠10</a:t>
-                      </a:r>
-                      <a:endParaRPr lang="en-US" sz="850" dirty="0">
-                        <a:latin typeface="Meiryo" charset="0"/>
-                        <a:ea typeface="Meiryo" charset="0"/>
-                        <a:cs typeface="Meiryo" charset="0"/>
-                      </a:endParaRPr>
-                    </a:p>
-                  </a:txBody>
-                  <a:tcPr marL="54864" marR="54864" marT="18288" marB="18288" anchor="ctr">
-                    <a:lnL w="0" cap="flat" cmpd="sng" algn="ctr">
-                      <a:noFill/>
-                    </a:lnL>
-                    <a:lnR w="0" cap="flat" cmpd="sng" algn="ctr">
-                      <a:noFill/>
-                    </a:lnR>
-                    <a:lnT w="0" cap="flat" cmpd="sng" algn="ctr">
-                      <a:noFill/>
-                    </a:lnT>
-                    <a:lnB w="9525" cap="flat" cmpd="sng" algn="ctr">
-                      <a:solidFill>
-                        <a:srgbClr val="BFBFBF"/>
-                      </a:solidFill>
-                      <a:prstDash val="solid"/>
-                      <a:round/>
-                      <a:headEnd type="none" w="med" len="med"/>
-                      <a:tailEnd type="none" w="med" len="med"/>
-                    </a:lnB>
-                    <a:solidFill>
-                      <a:srgbClr val="FFFFFF"/>
-                    </a:solidFill>
-                  </a:tcPr>
-                </a:tc>
-              </a:tr>
-              <a:tr h="274320">
-                <a:tc>
-                  <a:txBody>
-                    <a:bodyPr/>
-                    <a:lstStyle/>
-                    <a:p>
-                      <a:pPr algn="l" indent="0" marL="0">
-                        <a:buNone/>
-                      </a:pPr>
-                      <a:r>
-                        <a:rPr lang="en-US" sz="850" dirty="0">
-                          <a:solidFill>
-                            <a:srgbClr val="1A1A1A"/>
-                          </a:solidFill>
-                          <a:latin typeface="Meiryo" pitchFamily="34" charset="0"/>
-                          <a:ea typeface="Meiryo" pitchFamily="34" charset="-122"/>
-                          <a:cs typeface="Meiryo" pitchFamily="34" charset="-120"/>
-                        </a:rPr>
-                        <a:t>市場が小さくない？</a:t>
-                      </a:r>
-                      <a:endParaRPr lang="en-US" sz="850" dirty="0">
-                        <a:latin typeface="Meiryo" charset="0"/>
-                        <a:ea typeface="Meiryo" charset="0"/>
-                        <a:cs typeface="Meiryo" charset="0"/>
-                      </a:endParaRPr>
-                    </a:p>
-                  </a:txBody>
-                  <a:tcPr marL="54864" marR="54864" marT="18288" marB="18288" anchor="ctr">
-                    <a:lnL w="0" cap="flat" cmpd="sng" algn="ctr">
-                      <a:noFill/>
-                    </a:lnL>
-                    <a:lnR w="0" cap="flat" cmpd="sng" algn="ctr">
-                      <a:noFill/>
-                    </a:lnR>
-                    <a:lnT w="0" cap="flat" cmpd="sng" algn="ctr">
-                      <a:noFill/>
-                    </a:lnT>
-                    <a:lnB w="9525" cap="flat" cmpd="sng" algn="ctr">
-                      <a:solidFill>
-                        <a:srgbClr val="BFBFBF"/>
-                      </a:solidFill>
-                      <a:prstDash val="solid"/>
-                      <a:round/>
-                      <a:headEnd type="none" w="med" len="med"/>
-                      <a:tailEnd type="none" w="med" len="med"/>
-                    </a:lnB>
-                    <a:solidFill>
-                      <a:srgbClr val="FFFFFF"/>
-                    </a:solidFill>
-                  </a:tcPr>
-                </a:tc>
-                <a:tc>
-                  <a:txBody>
-                    <a:bodyPr/>
-                    <a:lstStyle/>
-                    <a:p>
-                      <a:pPr algn="l" indent="0" marL="0">
-                        <a:buNone/>
-                      </a:pPr>
-                      <a:r>
-                        <a:rPr lang="en-US" sz="850" dirty="0">
-                          <a:solidFill>
-                            <a:srgbClr val="1A1A1A"/>
-                          </a:solidFill>
-                          <a:latin typeface="Meiryo" pitchFamily="34" charset="0"/>
-                          <a:ea typeface="Meiryo" pitchFamily="34" charset="-122"/>
-                          <a:cs typeface="Meiryo" pitchFamily="34" charset="-120"/>
-                        </a:rPr>
-                        <a:t>5年目でターゲット市場の約1.8%。工場と海外は含めていません</a:t>
-                      </a:r>
-                      <a:endParaRPr lang="en-US" sz="850" dirty="0">
-                        <a:latin typeface="Meiryo" charset="0"/>
-                        <a:ea typeface="Meiryo" charset="0"/>
-                        <a:cs typeface="Meiryo" charset="0"/>
-                      </a:endParaRPr>
-                    </a:p>
-                  </a:txBody>
-                  <a:tcPr marL="54864" marR="54864" marT="18288" marB="18288" anchor="ctr">
-                    <a:lnL w="0" cap="flat" cmpd="sng" algn="ctr">
-                      <a:noFill/>
-                    </a:lnL>
-                    <a:lnR w="0" cap="flat" cmpd="sng" algn="ctr">
-                      <a:noFill/>
-                    </a:lnR>
-                    <a:lnT w="0" cap="flat" cmpd="sng" algn="ctr">
-                      <a:noFill/>
-                    </a:lnT>
-                    <a:lnB w="9525" cap="flat" cmpd="sng" algn="ctr">
-                      <a:solidFill>
-                        <a:srgbClr val="BFBFBF"/>
-                      </a:solidFill>
-                      <a:prstDash val="solid"/>
-                      <a:round/>
-                      <a:headEnd type="none" w="med" len="med"/>
-                      <a:tailEnd type="none" w="med" len="med"/>
-                    </a:lnB>
-                    <a:solidFill>
-                      <a:srgbClr val="FFFFFF"/>
-                    </a:solidFill>
-                  </a:tcPr>
-                </a:tc>
-                <a:tc>
-                  <a:txBody>
-                    <a:bodyPr/>
-                    <a:lstStyle/>
-                    <a:p>
-                      <a:pPr algn="ctr" indent="0" marL="0">
-                        <a:buNone/>
-                      </a:pPr>
-                      <a:r>
-                        <a:rPr lang="en-US" sz="850" dirty="0">
-                          <a:solidFill>
-                            <a:srgbClr val="1A1A1A"/>
-                          </a:solidFill>
-                          <a:latin typeface="Meiryo" pitchFamily="34" charset="0"/>
-                          <a:ea typeface="Meiryo" pitchFamily="34" charset="-122"/>
-                          <a:cs typeface="Meiryo" pitchFamily="34" charset="-120"/>
-                        </a:rPr>
-                        <a:t>根拠11</a:t>
-                      </a:r>
-                      <a:endParaRPr lang="en-US" sz="850" dirty="0">
-                        <a:latin typeface="Meiryo" charset="0"/>
-                        <a:ea typeface="Meiryo" charset="0"/>
-                        <a:cs typeface="Meiryo" charset="0"/>
-                      </a:endParaRPr>
-                    </a:p>
-                  </a:txBody>
-                  <a:tcPr marL="54864" marR="54864" marT="18288" marB="18288" anchor="ctr">
-                    <a:lnL w="0" cap="flat" cmpd="sng" algn="ctr">
-                      <a:noFill/>
-                    </a:lnL>
-                    <a:lnR w="0" cap="flat" cmpd="sng" algn="ctr">
-                      <a:noFill/>
-                    </a:lnR>
-                    <a:lnT w="0" cap="flat" cmpd="sng" algn="ctr">
-                      <a:noFill/>
-                    </a:lnT>
-                    <a:lnB w="9525" cap="flat" cmpd="sng" algn="ctr">
-                      <a:solidFill>
-                        <a:srgbClr val="BFBFBF"/>
-                      </a:solidFill>
-                      <a:prstDash val="solid"/>
-                      <a:round/>
-                      <a:headEnd type="none" w="med" len="med"/>
-                      <a:tailEnd type="none" w="med" len="med"/>
-                    </a:lnB>
-                    <a:solidFill>
-                      <a:srgbClr val="FFFFFF"/>
-                    </a:solidFill>
-                  </a:tcPr>
-                </a:tc>
-              </a:tr>
-              <a:tr h="274320">
-                <a:tc>
-                  <a:txBody>
-                    <a:bodyPr/>
-                    <a:lstStyle/>
-                    <a:p>
-                      <a:pPr algn="l" indent="0" marL="0">
-                        <a:buNone/>
-                      </a:pPr>
-                      <a:r>
-                        <a:rPr lang="en-US" sz="850" dirty="0">
-                          <a:solidFill>
-                            <a:srgbClr val="1A1A1A"/>
-                          </a:solidFill>
-                          <a:latin typeface="Meiryo" pitchFamily="34" charset="0"/>
-                          <a:ea typeface="Meiryo" pitchFamily="34" charset="-122"/>
-                          <a:cs typeface="Meiryo" pitchFamily="34" charset="-120"/>
-                        </a:rPr>
-                        <a:t>あなたが倒れたら？</a:t>
-                      </a:r>
-                      <a:endParaRPr lang="en-US" sz="850" dirty="0">
-                        <a:latin typeface="Meiryo" charset="0"/>
-                        <a:ea typeface="Meiryo" charset="0"/>
-                        <a:cs typeface="Meiryo" charset="0"/>
-                      </a:endParaRPr>
-                    </a:p>
-                  </a:txBody>
-                  <a:tcPr marL="54864" marR="54864" marT="18288" marB="18288" anchor="ctr">
-                    <a:lnL w="0" cap="flat" cmpd="sng" algn="ctr">
-                      <a:noFill/>
-                    </a:lnL>
-                    <a:lnR w="0" cap="flat" cmpd="sng" algn="ctr">
-                      <a:noFill/>
-                    </a:lnR>
-                    <a:lnT w="0" cap="flat" cmpd="sng" algn="ctr">
-                      <a:noFill/>
-                    </a:lnT>
-                    <a:lnB w="9525" cap="flat" cmpd="sng" algn="ctr">
-                      <a:solidFill>
-                        <a:srgbClr val="BFBFBF"/>
-                      </a:solidFill>
-                      <a:prstDash val="solid"/>
-                      <a:round/>
-                      <a:headEnd type="none" w="med" len="med"/>
-                      <a:tailEnd type="none" w="med" len="med"/>
-                    </a:lnB>
-                    <a:solidFill>
-                      <a:srgbClr val="FFFFFF"/>
-                    </a:solidFill>
-                  </a:tcPr>
-                </a:tc>
-                <a:tc>
-                  <a:txBody>
-                    <a:bodyPr/>
-                    <a:lstStyle/>
-                    <a:p>
-                      <a:pPr algn="l" indent="0" marL="0">
-                        <a:buNone/>
-                      </a:pPr>
-                      <a:r>
-                        <a:rPr lang="en-US" sz="850" dirty="0">
-                          <a:solidFill>
-                            <a:srgbClr val="1A1A1A"/>
-                          </a:solidFill>
-                          <a:latin typeface="Meiryo" pitchFamily="34" charset="0"/>
-                          <a:ea typeface="Meiryo" pitchFamily="34" charset="-122"/>
-                          <a:cs typeface="Meiryo" pitchFamily="34" charset="-120"/>
-                        </a:rPr>
-                        <a:t>役割を絞り判断基準を先に決め、1か月不在でも回る形にします</a:t>
-                      </a:r>
-                      <a:endParaRPr lang="en-US" sz="850" dirty="0">
-                        <a:latin typeface="Meiryo" charset="0"/>
-                        <a:ea typeface="Meiryo" charset="0"/>
-                        <a:cs typeface="Meiryo" charset="0"/>
-                      </a:endParaRPr>
-                    </a:p>
-                  </a:txBody>
-                  <a:tcPr marL="54864" marR="54864" marT="18288" marB="18288" anchor="ctr">
-                    <a:lnL w="0" cap="flat" cmpd="sng" algn="ctr">
-                      <a:noFill/>
-                    </a:lnL>
-                    <a:lnR w="0" cap="flat" cmpd="sng" algn="ctr">
-                      <a:noFill/>
-                    </a:lnR>
-                    <a:lnT w="0" cap="flat" cmpd="sng" algn="ctr">
-                      <a:noFill/>
-                    </a:lnT>
-                    <a:lnB w="9525" cap="flat" cmpd="sng" algn="ctr">
-                      <a:solidFill>
-                        <a:srgbClr val="BFBFBF"/>
-                      </a:solidFill>
-                      <a:prstDash val="solid"/>
-                      <a:round/>
-                      <a:headEnd type="none" w="med" len="med"/>
-                      <a:tailEnd type="none" w="med" len="med"/>
-                    </a:lnB>
-                    <a:solidFill>
-                      <a:srgbClr val="FFFFFF"/>
-                    </a:solidFill>
-                  </a:tcPr>
-                </a:tc>
-                <a:tc>
-                  <a:txBody>
-                    <a:bodyPr/>
-                    <a:lstStyle/>
-                    <a:p>
-                      <a:pPr algn="ctr" indent="0" marL="0">
-                        <a:buNone/>
-                      </a:pPr>
-                      <a:r>
-                        <a:rPr lang="en-US" sz="850" dirty="0">
-                          <a:solidFill>
-                            <a:srgbClr val="1A1A1A"/>
-                          </a:solidFill>
-                          <a:latin typeface="Meiryo" pitchFamily="34" charset="0"/>
-                          <a:ea typeface="Meiryo" pitchFamily="34" charset="-122"/>
-                          <a:cs typeface="Meiryo" pitchFamily="34" charset="-120"/>
-                        </a:rPr>
-                        <a:t>発表資料リスク</a:t>
+                        <a:t>−20〜50℃</a:t>
                       </a:r>
                       <a:endParaRPr lang="en-US" sz="850" dirty="0">
                         <a:latin typeface="Meiryo" charset="0"/>
@@ -17401,6 +16732,402 @@
       <p:sp>
         <p:nvSpPr>
           <p:cNvPr id="6" name="Text 2"/>
+          <p:cNvSpPr txBox="1"/>
+          <p:nvPr/>
+        </p:nvSpPr>
+        <p:spPr>
+          <a:xfrm>
+            <a:off x="365760" y="3063240"/>
+            <a:ext cx="4846320" cy="411480"/>
+          </a:xfrm>
+          <a:prstGeom prst="rect">
+            <a:avLst/>
+          </a:prstGeom>
+          <a:noFill/>
+          <a:ln/>
+        </p:spPr>
+        <p:txBody>
+          <a:bodyPr wrap="square" lIns="0" tIns="0" rIns="0" bIns="0" rtlCol="0" anchor="t"/>
+          <a:lstStyle/>
+          <a:p>
+            <a:pPr algn="l" indent="0" marL="0">
+              <a:lnSpc>
+                <a:spcPct val="115000"/>
+              </a:lnSpc>
+              <a:buNone/>
+            </a:pPr>
+            <a:r>
+              <a:rPr lang="en-US" sz="850" dirty="0">
+                <a:solidFill>
+                  <a:srgbClr val="4D4D4D"/>
+                </a:solidFill>
+                <a:latin typeface="Meiryo" pitchFamily="34" charset="0"/>
+                <a:ea typeface="Meiryo" pitchFamily="34" charset="-122"/>
+                <a:cs typeface="Meiryo" pitchFamily="34" charset="-120"/>
+              </a:rPr>
+              <a:t>ARグラス：Metaの表示付きグラスは2025年発売。両眼ARグラスの一般発売は2027年と報道（公式発表ではない）</a:t>
+            </a:r>
+            <a:endParaRPr lang="en-US" sz="850" dirty="0"/>
+          </a:p>
+        </p:txBody>
+      </p:sp>
+      <p:sp>
+        <p:nvSpPr>
+          <p:cNvPr id="7" name="Shape 3"/>
+          <p:cNvSpPr/>
+          <p:nvPr/>
+        </p:nvSpPr>
+        <p:spPr>
+          <a:xfrm>
+            <a:off x="5440680" y="1051560"/>
+            <a:ext cx="3337560" cy="2423160"/>
+          </a:xfrm>
+          <a:prstGeom prst="rect">
+            <a:avLst/>
+          </a:prstGeom>
+          <a:solidFill>
+            <a:srgbClr val="F2F2F2"/>
+          </a:solidFill>
+          <a:ln/>
+        </p:spPr>
+      </p:sp>
+      <p:sp>
+        <p:nvSpPr>
+          <p:cNvPr id="8" name="Text 4"/>
+          <p:cNvSpPr txBox="1"/>
+          <p:nvPr/>
+        </p:nvSpPr>
+        <p:spPr>
+          <a:xfrm>
+            <a:off x="5577840" y="1097280"/>
+            <a:ext cx="3063240" cy="2331720"/>
+          </a:xfrm>
+          <a:prstGeom prst="rect">
+            <a:avLst/>
+          </a:prstGeom>
+          <a:noFill/>
+          <a:ln/>
+        </p:spPr>
+        <p:txBody>
+          <a:bodyPr wrap="square" lIns="0" tIns="0" rIns="0" bIns="0" rtlCol="0" anchor="ctr"/>
+          <a:lstStyle/>
+          <a:p>
+            <a:pPr algn="l" indent="0" marL="0">
+              <a:lnSpc>
+                <a:spcPct val="115000"/>
+              </a:lnSpc>
+              <a:spcAft>
+                <a:spcPts val="200"/>
+              </a:spcAft>
+              <a:buNone/>
+            </a:pPr>
+            <a:r>
+              <a:rPr lang="en-US" sz="950" b="1" dirty="0">
+                <a:solidFill>
+                  <a:srgbClr val="B8692E"/>
+                </a:solidFill>
+                <a:latin typeface="Meiryo" pitchFamily="34" charset="0"/>
+                <a:ea typeface="Meiryo" pitchFamily="34" charset="-122"/>
+                <a:cs typeface="Meiryo" pitchFamily="34" charset="-120"/>
+              </a:rPr>
+              <a:t>手元ARの実証（3か月）</a:t>
+            </a:r>
+            <a:endParaRPr lang="en-US" sz="950" dirty="0"/>
+          </a:p>
+          <a:p>
+            <a:pPr algn="l" indent="0" marL="0">
+              <a:lnSpc>
+                <a:spcPct val="115000"/>
+              </a:lnSpc>
+              <a:spcAft>
+                <a:spcPts val="200"/>
+              </a:spcAft>
+              <a:buNone/>
+            </a:pPr>
+            <a:r>
+              <a:rPr lang="en-US" sz="950" dirty="0">
+                <a:solidFill>
+                  <a:srgbClr val="1A1A1A"/>
+                </a:solidFill>
+                <a:latin typeface="Meiryo" pitchFamily="34" charset="0"/>
+                <a:ea typeface="Meiryo" pitchFamily="34" charset="-122"/>
+                <a:cs typeface="Meiryo" pitchFamily="34" charset="-120"/>
+              </a:rPr>
+              <a:t>対象：よく使うジョイント1種類</a:t>
+            </a:r>
+            <a:endParaRPr lang="en-US" sz="950" dirty="0"/>
+          </a:p>
+          <a:p>
+            <a:pPr algn="l" indent="0" marL="0">
+              <a:lnSpc>
+                <a:spcPct val="115000"/>
+              </a:lnSpc>
+              <a:spcAft>
+                <a:spcPts val="200"/>
+              </a:spcAft>
+              <a:buNone/>
+            </a:pPr>
+            <a:r>
+              <a:rPr lang="en-US" sz="950" dirty="0">
+                <a:solidFill>
+                  <a:srgbClr val="1A1A1A"/>
+                </a:solidFill>
+                <a:latin typeface="Meiryo" pitchFamily="34" charset="0"/>
+                <a:ea typeface="Meiryo" pitchFamily="34" charset="-122"/>
+                <a:cs typeface="Meiryo" pitchFamily="34" charset="-120"/>
+              </a:rPr>
+              <a:t>1か月目：紙の図面で基準を測る</a:t>
+            </a:r>
+            <a:endParaRPr lang="en-US" sz="950" dirty="0"/>
+          </a:p>
+          <a:p>
+            <a:pPr algn="l" indent="0" marL="0">
+              <a:lnSpc>
+                <a:spcPct val="115000"/>
+              </a:lnSpc>
+              <a:spcAft>
+                <a:spcPts val="200"/>
+              </a:spcAft>
+              <a:buNone/>
+            </a:pPr>
+            <a:r>
+              <a:rPr lang="en-US" sz="950" dirty="0">
+                <a:solidFill>
+                  <a:srgbClr val="1A1A1A"/>
+                </a:solidFill>
+                <a:latin typeface="Meiryo" pitchFamily="34" charset="0"/>
+                <a:ea typeface="Meiryo" pitchFamily="34" charset="-122"/>
+                <a:cs typeface="Meiryo" pitchFamily="34" charset="-120"/>
+              </a:rPr>
+              <a:t>2〜3か月目：ARで同じ作業</a:t>
+            </a:r>
+            <a:endParaRPr lang="en-US" sz="950" dirty="0"/>
+          </a:p>
+          <a:p>
+            <a:pPr algn="l" indent="0" marL="0">
+              <a:lnSpc>
+                <a:spcPct val="115000"/>
+              </a:lnSpc>
+              <a:spcAft>
+                <a:spcPts val="200"/>
+              </a:spcAft>
+              <a:buNone/>
+            </a:pPr>
+            <a:r>
+              <a:rPr lang="en-US" sz="950" b="1" dirty="0">
+                <a:solidFill>
+                  <a:srgbClr val="1A1A1A"/>
+                </a:solidFill>
+                <a:latin typeface="Meiryo" pitchFamily="34" charset="0"/>
+                <a:ea typeface="Meiryo" pitchFamily="34" charset="-122"/>
+                <a:cs typeface="Meiryo" pitchFamily="34" charset="-120"/>
+              </a:rPr>
+              <a:t>測る数字</a:t>
+            </a:r>
+            <a:endParaRPr lang="en-US" sz="950" dirty="0"/>
+          </a:p>
+          <a:p>
+            <a:pPr algn="l" indent="0" marL="0">
+              <a:lnSpc>
+                <a:spcPct val="115000"/>
+              </a:lnSpc>
+              <a:spcAft>
+                <a:spcPts val="200"/>
+              </a:spcAft>
+              <a:buNone/>
+            </a:pPr>
+            <a:r>
+              <a:rPr lang="en-US" sz="950" dirty="0">
+                <a:solidFill>
+                  <a:srgbClr val="1A1A1A"/>
+                </a:solidFill>
+                <a:latin typeface="Meiryo" pitchFamily="34" charset="0"/>
+                <a:ea typeface="Meiryo" pitchFamily="34" charset="-122"/>
+                <a:cs typeface="Meiryo" pitchFamily="34" charset="-120"/>
+              </a:rPr>
+              <a:t>① 手戻り・施工ミスの件数</a:t>
+            </a:r>
+            <a:endParaRPr lang="en-US" sz="950" dirty="0"/>
+          </a:p>
+          <a:p>
+            <a:pPr algn="l" indent="0" marL="0">
+              <a:lnSpc>
+                <a:spcPct val="115000"/>
+              </a:lnSpc>
+              <a:spcAft>
+                <a:spcPts val="200"/>
+              </a:spcAft>
+              <a:buNone/>
+            </a:pPr>
+            <a:r>
+              <a:rPr lang="en-US" sz="950" dirty="0">
+                <a:solidFill>
+                  <a:srgbClr val="1A1A1A"/>
+                </a:solidFill>
+                <a:latin typeface="Meiryo" pitchFamily="34" charset="0"/>
+                <a:ea typeface="Meiryo" pitchFamily="34" charset="-122"/>
+                <a:cs typeface="Meiryo" pitchFamily="34" charset="-120"/>
+              </a:rPr>
+              <a:t>② 1ジョイントの作業時間</a:t>
+            </a:r>
+            <a:endParaRPr lang="en-US" sz="950" dirty="0"/>
+          </a:p>
+          <a:p>
+            <a:pPr algn="l" indent="0" marL="0">
+              <a:lnSpc>
+                <a:spcPct val="115000"/>
+              </a:lnSpc>
+              <a:spcAft>
+                <a:spcPts val="200"/>
+              </a:spcAft>
+              <a:buNone/>
+            </a:pPr>
+            <a:r>
+              <a:rPr lang="en-US" sz="950" dirty="0">
+                <a:solidFill>
+                  <a:srgbClr val="1A1A1A"/>
+                </a:solidFill>
+                <a:latin typeface="Meiryo" pitchFamily="34" charset="0"/>
+                <a:ea typeface="Meiryo" pitchFamily="34" charset="-122"/>
+                <a:cs typeface="Meiryo" pitchFamily="34" charset="-120"/>
+              </a:rPr>
+              <a:t>③ 新人が独り立ちするまでの期間</a:t>
+            </a:r>
+            <a:endParaRPr lang="en-US" sz="950" dirty="0"/>
+          </a:p>
+        </p:txBody>
+      </p:sp>
+      <p:sp>
+        <p:nvSpPr>
+          <p:cNvPr id="9" name="Shape 5"/>
+          <p:cNvSpPr/>
+          <p:nvPr/>
+        </p:nvSpPr>
+        <p:spPr>
+          <a:xfrm>
+            <a:off x="365760" y="3657600"/>
+            <a:ext cx="8412480" cy="777240"/>
+          </a:xfrm>
+          <a:prstGeom prst="rect">
+            <a:avLst/>
+          </a:prstGeom>
+          <a:solidFill>
+            <a:srgbClr val="1A1A1A"/>
+          </a:solidFill>
+          <a:ln/>
+        </p:spPr>
+      </p:sp>
+      <p:sp>
+        <p:nvSpPr>
+          <p:cNvPr id="10" name="Text 6"/>
+          <p:cNvSpPr txBox="1"/>
+          <p:nvPr/>
+        </p:nvSpPr>
+        <p:spPr>
+          <a:xfrm>
+            <a:off x="502920" y="3657600"/>
+            <a:ext cx="8138160" cy="777240"/>
+          </a:xfrm>
+          <a:prstGeom prst="rect">
+            <a:avLst/>
+          </a:prstGeom>
+          <a:noFill/>
+          <a:ln/>
+        </p:spPr>
+        <p:txBody>
+          <a:bodyPr wrap="square" lIns="0" tIns="0" rIns="0" bIns="0" rtlCol="0" anchor="ctr"/>
+          <a:lstStyle/>
+          <a:p>
+            <a:pPr algn="l" indent="0" marL="0">
+              <a:lnSpc>
+                <a:spcPct val="115000"/>
+              </a:lnSpc>
+              <a:spcAft>
+                <a:spcPts val="300"/>
+              </a:spcAft>
+              <a:buNone/>
+            </a:pPr>
+            <a:r>
+              <a:rPr lang="en-US" sz="900" b="1" dirty="0">
+                <a:solidFill>
+                  <a:srgbClr val="E3A774"/>
+                </a:solidFill>
+                <a:latin typeface="Meiryo" pitchFamily="34" charset="0"/>
+                <a:ea typeface="Meiryo" pitchFamily="34" charset="-122"/>
+                <a:cs typeface="Meiryo" pitchFamily="34" charset="-120"/>
+              </a:rPr>
+              <a:t>聞かれたら：</a:t>
+            </a:r>
+            <a:pPr algn="l" indent="0" marL="0">
+              <a:lnSpc>
+                <a:spcPct val="115000"/>
+              </a:lnSpc>
+              <a:spcAft>
+                <a:spcPts val="300"/>
+              </a:spcAft>
+              <a:buNone/>
+            </a:pPr>
+            <a:r>
+              <a:rPr lang="en-US" sz="900" dirty="0">
+                <a:solidFill>
+                  <a:srgbClr val="FFFFFF"/>
+                </a:solidFill>
+                <a:latin typeface="Meiryo" pitchFamily="34" charset="0"/>
+                <a:ea typeface="Meiryo" pitchFamily="34" charset="-122"/>
+                <a:cs typeface="Meiryo" pitchFamily="34" charset="-120"/>
+              </a:rPr>
+              <a:t>「グラスは作りません。作るのはアプリ・AI・データ基盤と、端末を壊さない保護カバーとヘルメット取付具です。端末が進化したら乗り換えます」</a:t>
+            </a:r>
+            <a:endParaRPr lang="en-US" sz="900" dirty="0"/>
+          </a:p>
+          <a:p>
+            <a:pPr algn="l" indent="0" marL="0">
+              <a:lnSpc>
+                <a:spcPct val="115000"/>
+              </a:lnSpc>
+              <a:spcAft>
+                <a:spcPts val="300"/>
+              </a:spcAft>
+              <a:buNone/>
+            </a:pPr>
+            <a:r>
+              <a:rPr lang="en-US" sz="900" b="1" dirty="0">
+                <a:solidFill>
+                  <a:srgbClr val="E3A774"/>
+                </a:solidFill>
+                <a:latin typeface="Meiryo" pitchFamily="34" charset="0"/>
+                <a:ea typeface="Meiryo" pitchFamily="34" charset="-122"/>
+                <a:cs typeface="Meiryo" pitchFamily="34" charset="-120"/>
+              </a:rPr>
+              <a:t>初期コスト：</a:t>
+            </a:r>
+            <a:pPr algn="l" indent="0" marL="0">
+              <a:lnSpc>
+                <a:spcPct val="115000"/>
+              </a:lnSpc>
+              <a:spcAft>
+                <a:spcPts val="300"/>
+              </a:spcAft>
+              <a:buNone/>
+            </a:pPr>
+            <a:r>
+              <a:rPr lang="en-US" sz="900" dirty="0">
+                <a:solidFill>
+                  <a:srgbClr val="FFFFFF"/>
+                </a:solidFill>
+                <a:latin typeface="Meiryo" pitchFamily="34" charset="0"/>
+                <a:ea typeface="Meiryo" pitchFamily="34" charset="-122"/>
+                <a:cs typeface="Meiryo" pitchFamily="34" charset="-120"/>
+              </a:rPr>
+              <a:t>組立図の3D化が必要。1種類に絞って始め、型を作ってから広げる</a:t>
+            </a:r>
+            <a:endParaRPr lang="en-US" sz="900" dirty="0"/>
+          </a:p>
+        </p:txBody>
+      </p:sp>
+      <p:sp>
+        <p:nvSpPr>
+          <p:cNvPr id="11" name="Text 7"/>
           <p:cNvSpPr txBox="1"/>
           <p:nvPr/>
         </p:nvSpPr>
@@ -17434,7 +17161,7 @@
                 <a:ea typeface="Meiryo" pitchFamily="34" charset="-122"/>
                 <a:cs typeface="Meiryo" pitchFamily="34" charset="-120"/>
               </a:rPr>
-              <a:t>詳しい想定問答は「令和の虎_想定問答.md」</a:t>
+              <a:t>端末の仕様は販売店の公表値。RealWear公式の仕様書で確認する。保護めがねとしての規格適合は要確認</a:t>
             </a:r>
             <a:endParaRPr lang="en-US" sz="800" dirty="0"/>
           </a:p>
@@ -17543,6 +17270,2381 @@
             <a:r>
               <a:rPr lang="en-US" sz="2000" b="1" dirty="0">
                 <a:solidFill>
+                  <a:srgbClr val="B8692E"/>
+                </a:solidFill>
+                <a:latin typeface="Meiryo" pitchFamily="34" charset="0"/>
+                <a:ea typeface="Meiryo" pitchFamily="34" charset="-122"/>
+                <a:cs typeface="Meiryo" pitchFamily="34" charset="-120"/>
+              </a:rPr>
+              <a:t>根拠14 </a:t>
+            </a:r>
+            <a:pPr algn="l" indent="0" marL="0">
+              <a:lnSpc>
+                <a:spcPct val="115000"/>
+              </a:lnSpc>
+              <a:buNone/>
+            </a:pPr>
+            <a:r>
+              <a:rPr lang="en-US" sz="2000" b="1" dirty="0">
+                <a:solidFill>
+                  <a:srgbClr val="1A1A1A"/>
+                </a:solidFill>
+                <a:latin typeface="Meiryo" pitchFamily="34" charset="0"/>
+                <a:ea typeface="Meiryo" pitchFamily="34" charset="-122"/>
+                <a:cs typeface="Meiryo" pitchFamily="34" charset="-120"/>
+              </a:rPr>
+              <a:t>厳しい質問 ─ 数字 → 式 → 前提の順で答える</a:t>
+            </a:r>
+            <a:endParaRPr lang="en-US" sz="2000" dirty="0"/>
+          </a:p>
+        </p:txBody>
+      </p:sp>
+      <p:sp>
+        <p:nvSpPr>
+          <p:cNvPr id="4" name="lead"/>
+          <p:cNvSpPr txBox="1"/>
+          <p:nvPr/>
+        </p:nvSpPr>
+        <p:spPr>
+          <a:xfrm>
+            <a:off x="365760" y="658368"/>
+            <a:ext cx="7955280" cy="256032"/>
+          </a:xfrm>
+          <a:prstGeom prst="rect">
+            <a:avLst/>
+          </a:prstGeom>
+          <a:noFill/>
+          <a:ln/>
+        </p:spPr>
+        <p:txBody>
+          <a:bodyPr wrap="square" lIns="0" tIns="0" rIns="0" bIns="0" rtlCol="0" anchor="ctr"/>
+          <a:lstStyle/>
+          <a:p>
+            <a:pPr algn="l" indent="0" marL="0">
+              <a:lnSpc>
+                <a:spcPct val="115000"/>
+              </a:lnSpc>
+              <a:buNone/>
+            </a:pPr>
+            <a:r>
+              <a:rPr lang="en-US" sz="1200" dirty="0">
+                <a:solidFill>
+                  <a:srgbClr val="4D4D4D"/>
+                </a:solidFill>
+                <a:latin typeface="Meiryo" pitchFamily="34" charset="0"/>
+                <a:ea typeface="Meiryo" pitchFamily="34" charset="-122"/>
+                <a:cs typeface="Meiryo" pitchFamily="34" charset="-120"/>
+              </a:rPr>
+              <a:t>一言で答え、根拠のページを示す</a:t>
+            </a:r>
+            <a:endParaRPr lang="en-US" sz="1200" dirty="0"/>
+          </a:p>
+        </p:txBody>
+      </p:sp>
+      <p:graphicFrame>
+        <p:nvGraphicFramePr>
+          <p:cNvPr id="16" name="qa"/>
+          <p:cNvGraphicFramePr>
+            <a:graphicFrameLocks noGrp="1"/>
+          </p:cNvGraphicFramePr>
+          <p:nvPr>
+            <p:extLst>
+              <p:ext uri="{D42A27DB-BD31-4B8C-83A1-F6EECF244321}">
+                <p14:modId xmlns:p14="http://schemas.microsoft.com/office/powerpoint/2010/main" val="1579011935"/>
+              </p:ext>
+            </p:extLst>
+          </p:nvPr>
+        </p:nvGraphicFramePr>
+        <p:xfrm>
+          <a:off x="365760" y="1024128"/>
+          <a:ext cx="8412480" cy="914400"/>
+        </p:xfrm>
+        <a:graphic>
+          <a:graphicData uri="http://schemas.openxmlformats.org/drawingml/2006/table">
+            <a:tbl>
+              <a:tblPr/>
+              <a:tblGrid>
+                <a:gridCol w="1920240"/>
+                <a:gridCol w="5394960"/>
+                <a:gridCol w="1097280"/>
+              </a:tblGrid>
+              <a:tr h="237744">
+                <a:tc>
+                  <a:txBody>
+                    <a:bodyPr/>
+                    <a:lstStyle/>
+                    <a:p>
+                      <a:pPr algn="l" indent="0" marL="0">
+                        <a:buNone/>
+                      </a:pPr>
+                      <a:r>
+                        <a:rPr lang="en-US" sz="800" b="1" dirty="0">
+                          <a:solidFill>
+                            <a:srgbClr val="1A1A1A"/>
+                          </a:solidFill>
+                          <a:latin typeface="Meiryo" pitchFamily="34" charset="0"/>
+                          <a:ea typeface="Meiryo" pitchFamily="34" charset="-122"/>
+                          <a:cs typeface="Meiryo" pitchFamily="34" charset="-120"/>
+                        </a:rPr>
+                        <a:t>質問</a:t>
+                      </a:r>
+                      <a:endParaRPr lang="en-US" sz="800" dirty="0">
+                        <a:latin typeface="Meiryo" charset="0"/>
+                        <a:ea typeface="Meiryo" charset="0"/>
+                        <a:cs typeface="Meiryo" charset="0"/>
+                      </a:endParaRPr>
+                    </a:p>
+                  </a:txBody>
+                  <a:tcPr marL="54864" marR="54864" marT="18288" marB="18288" anchor="ctr">
+                    <a:lnL w="0" cap="flat" cmpd="sng" algn="ctr">
+                      <a:noFill/>
+                    </a:lnL>
+                    <a:lnR w="0" cap="flat" cmpd="sng" algn="ctr">
+                      <a:noFill/>
+                    </a:lnR>
+                    <a:lnT w="0" cap="flat" cmpd="sng" algn="ctr">
+                      <a:noFill/>
+                    </a:lnT>
+                    <a:lnB w="19050" cap="flat" cmpd="sng" algn="ctr">
+                      <a:solidFill>
+                        <a:srgbClr val="1A1A1A"/>
+                      </a:solidFill>
+                      <a:prstDash val="solid"/>
+                      <a:round/>
+                      <a:headEnd type="none" w="med" len="med"/>
+                      <a:tailEnd type="none" w="med" len="med"/>
+                    </a:lnB>
+                    <a:solidFill>
+                      <a:srgbClr val="F2F2F2"/>
+                    </a:solidFill>
+                  </a:tcPr>
+                </a:tc>
+                <a:tc>
+                  <a:txBody>
+                    <a:bodyPr/>
+                    <a:lstStyle/>
+                    <a:p>
+                      <a:pPr algn="l" indent="0" marL="0">
+                        <a:buNone/>
+                      </a:pPr>
+                      <a:r>
+                        <a:rPr lang="en-US" sz="800" b="1" dirty="0">
+                          <a:solidFill>
+                            <a:srgbClr val="1A1A1A"/>
+                          </a:solidFill>
+                          <a:latin typeface="Meiryo" pitchFamily="34" charset="0"/>
+                          <a:ea typeface="Meiryo" pitchFamily="34" charset="-122"/>
+                          <a:cs typeface="Meiryo" pitchFamily="34" charset="-120"/>
+                        </a:rPr>
+                        <a:t>一言の答え</a:t>
+                      </a:r>
+                      <a:endParaRPr lang="en-US" sz="800" dirty="0">
+                        <a:latin typeface="Meiryo" charset="0"/>
+                        <a:ea typeface="Meiryo" charset="0"/>
+                        <a:cs typeface="Meiryo" charset="0"/>
+                      </a:endParaRPr>
+                    </a:p>
+                  </a:txBody>
+                  <a:tcPr marL="54864" marR="54864" marT="18288" marB="18288" anchor="ctr">
+                    <a:lnL w="0" cap="flat" cmpd="sng" algn="ctr">
+                      <a:noFill/>
+                    </a:lnL>
+                    <a:lnR w="0" cap="flat" cmpd="sng" algn="ctr">
+                      <a:noFill/>
+                    </a:lnR>
+                    <a:lnT w="0" cap="flat" cmpd="sng" algn="ctr">
+                      <a:noFill/>
+                    </a:lnT>
+                    <a:lnB w="19050" cap="flat" cmpd="sng" algn="ctr">
+                      <a:solidFill>
+                        <a:srgbClr val="1A1A1A"/>
+                      </a:solidFill>
+                      <a:prstDash val="solid"/>
+                      <a:round/>
+                      <a:headEnd type="none" w="med" len="med"/>
+                      <a:tailEnd type="none" w="med" len="med"/>
+                    </a:lnB>
+                    <a:solidFill>
+                      <a:srgbClr val="F2F2F2"/>
+                    </a:solidFill>
+                  </a:tcPr>
+                </a:tc>
+                <a:tc>
+                  <a:txBody>
+                    <a:bodyPr/>
+                    <a:lstStyle/>
+                    <a:p>
+                      <a:pPr algn="ctr" indent="0" marL="0">
+                        <a:buNone/>
+                      </a:pPr>
+                      <a:r>
+                        <a:rPr lang="en-US" sz="800" b="1" dirty="0">
+                          <a:solidFill>
+                            <a:srgbClr val="1A1A1A"/>
+                          </a:solidFill>
+                          <a:latin typeface="Meiryo" pitchFamily="34" charset="0"/>
+                          <a:ea typeface="Meiryo" pitchFamily="34" charset="-122"/>
+                          <a:cs typeface="Meiryo" pitchFamily="34" charset="-120"/>
+                        </a:rPr>
+                        <a:t>根拠</a:t>
+                      </a:r>
+                      <a:endParaRPr lang="en-US" sz="800" dirty="0">
+                        <a:latin typeface="Meiryo" charset="0"/>
+                        <a:ea typeface="Meiryo" charset="0"/>
+                        <a:cs typeface="Meiryo" charset="0"/>
+                      </a:endParaRPr>
+                    </a:p>
+                  </a:txBody>
+                  <a:tcPr marL="54864" marR="54864" marT="18288" marB="18288" anchor="ctr">
+                    <a:lnL w="0" cap="flat" cmpd="sng" algn="ctr">
+                      <a:noFill/>
+                    </a:lnL>
+                    <a:lnR w="0" cap="flat" cmpd="sng" algn="ctr">
+                      <a:noFill/>
+                    </a:lnR>
+                    <a:lnT w="0" cap="flat" cmpd="sng" algn="ctr">
+                      <a:noFill/>
+                    </a:lnT>
+                    <a:lnB w="19050" cap="flat" cmpd="sng" algn="ctr">
+                      <a:solidFill>
+                        <a:srgbClr val="1A1A1A"/>
+                      </a:solidFill>
+                      <a:prstDash val="solid"/>
+                      <a:round/>
+                      <a:headEnd type="none" w="med" len="med"/>
+                      <a:tailEnd type="none" w="med" len="med"/>
+                    </a:lnB>
+                    <a:solidFill>
+                      <a:srgbClr val="F2F2F2"/>
+                    </a:solidFill>
+                  </a:tcPr>
+                </a:tc>
+              </a:tr>
+              <a:tr h="237744">
+                <a:tc>
+                  <a:txBody>
+                    <a:bodyPr/>
+                    <a:lstStyle/>
+                    <a:p>
+                      <a:pPr algn="l" indent="0" marL="0">
+                        <a:buNone/>
+                      </a:pPr>
+                      <a:r>
+                        <a:rPr lang="en-US" sz="800" dirty="0">
+                          <a:solidFill>
+                            <a:srgbClr val="1A1A1A"/>
+                          </a:solidFill>
+                          <a:latin typeface="Meiryo" pitchFamily="34" charset="0"/>
+                          <a:ea typeface="Meiryo" pitchFamily="34" charset="-122"/>
+                          <a:cs typeface="Meiryo" pitchFamily="34" charset="-120"/>
+                        </a:rPr>
+                        <a:t>本当に年300万円払う？</a:t>
+                      </a:r>
+                      <a:endParaRPr lang="en-US" sz="800" dirty="0">
+                        <a:latin typeface="Meiryo" charset="0"/>
+                        <a:ea typeface="Meiryo" charset="0"/>
+                        <a:cs typeface="Meiryo" charset="0"/>
+                      </a:endParaRPr>
+                    </a:p>
+                  </a:txBody>
+                  <a:tcPr marL="54864" marR="54864" marT="18288" marB="18288" anchor="ctr">
+                    <a:lnL w="0" cap="flat" cmpd="sng" algn="ctr">
+                      <a:noFill/>
+                    </a:lnL>
+                    <a:lnR w="0" cap="flat" cmpd="sng" algn="ctr">
+                      <a:noFill/>
+                    </a:lnR>
+                    <a:lnT w="0" cap="flat" cmpd="sng" algn="ctr">
+                      <a:noFill/>
+                    </a:lnT>
+                    <a:lnB w="9525" cap="flat" cmpd="sng" algn="ctr">
+                      <a:solidFill>
+                        <a:srgbClr val="BFBFBF"/>
+                      </a:solidFill>
+                      <a:prstDash val="solid"/>
+                      <a:round/>
+                      <a:headEnd type="none" w="med" len="med"/>
+                      <a:tailEnd type="none" w="med" len="med"/>
+                    </a:lnB>
+                    <a:solidFill>
+                      <a:srgbClr val="FFFFFF"/>
+                    </a:solidFill>
+                  </a:tcPr>
+                </a:tc>
+                <a:tc>
+                  <a:txBody>
+                    <a:bodyPr/>
+                    <a:lstStyle/>
+                    <a:p>
+                      <a:pPr algn="l" indent="0" marL="0">
+                        <a:buNone/>
+                      </a:pPr>
+                      <a:r>
+                        <a:rPr lang="en-US" sz="800" dirty="0">
+                          <a:solidFill>
+                            <a:srgbClr val="1A1A1A"/>
+                          </a:solidFill>
+                          <a:latin typeface="Meiryo" pitchFamily="34" charset="0"/>
+                          <a:ea typeface="Meiryo" pitchFamily="34" charset="-122"/>
+                          <a:cs typeface="Meiryo" pitchFamily="34" charset="-120"/>
+                        </a:rPr>
+                        <a:t>月240万円分の時間が浮き、約2か月で元が取れます</a:t>
+                      </a:r>
+                      <a:endParaRPr lang="en-US" sz="800" dirty="0">
+                        <a:latin typeface="Meiryo" charset="0"/>
+                        <a:ea typeface="Meiryo" charset="0"/>
+                        <a:cs typeface="Meiryo" charset="0"/>
+                      </a:endParaRPr>
+                    </a:p>
+                  </a:txBody>
+                  <a:tcPr marL="54864" marR="54864" marT="18288" marB="18288" anchor="ctr">
+                    <a:lnL w="0" cap="flat" cmpd="sng" algn="ctr">
+                      <a:noFill/>
+                    </a:lnL>
+                    <a:lnR w="0" cap="flat" cmpd="sng" algn="ctr">
+                      <a:noFill/>
+                    </a:lnR>
+                    <a:lnT w="0" cap="flat" cmpd="sng" algn="ctr">
+                      <a:noFill/>
+                    </a:lnT>
+                    <a:lnB w="9525" cap="flat" cmpd="sng" algn="ctr">
+                      <a:solidFill>
+                        <a:srgbClr val="BFBFBF"/>
+                      </a:solidFill>
+                      <a:prstDash val="solid"/>
+                      <a:round/>
+                      <a:headEnd type="none" w="med" len="med"/>
+                      <a:tailEnd type="none" w="med" len="med"/>
+                    </a:lnB>
+                    <a:solidFill>
+                      <a:srgbClr val="FFFFFF"/>
+                    </a:solidFill>
+                  </a:tcPr>
+                </a:tc>
+                <a:tc>
+                  <a:txBody>
+                    <a:bodyPr/>
+                    <a:lstStyle/>
+                    <a:p>
+                      <a:pPr algn="ctr" indent="0" marL="0">
+                        <a:buNone/>
+                      </a:pPr>
+                      <a:r>
+                        <a:rPr lang="en-US" sz="800" dirty="0">
+                          <a:solidFill>
+                            <a:srgbClr val="1A1A1A"/>
+                          </a:solidFill>
+                          <a:latin typeface="Meiryo" pitchFamily="34" charset="0"/>
+                          <a:ea typeface="Meiryo" pitchFamily="34" charset="-122"/>
+                          <a:cs typeface="Meiryo" pitchFamily="34" charset="-120"/>
+                        </a:rPr>
+                        <a:t>根拠3・4</a:t>
+                      </a:r>
+                      <a:endParaRPr lang="en-US" sz="800" dirty="0">
+                        <a:latin typeface="Meiryo" charset="0"/>
+                        <a:ea typeface="Meiryo" charset="0"/>
+                        <a:cs typeface="Meiryo" charset="0"/>
+                      </a:endParaRPr>
+                    </a:p>
+                  </a:txBody>
+                  <a:tcPr marL="54864" marR="54864" marT="18288" marB="18288" anchor="ctr">
+                    <a:lnL w="0" cap="flat" cmpd="sng" algn="ctr">
+                      <a:noFill/>
+                    </a:lnL>
+                    <a:lnR w="0" cap="flat" cmpd="sng" algn="ctr">
+                      <a:noFill/>
+                    </a:lnR>
+                    <a:lnT w="0" cap="flat" cmpd="sng" algn="ctr">
+                      <a:noFill/>
+                    </a:lnT>
+                    <a:lnB w="9525" cap="flat" cmpd="sng" algn="ctr">
+                      <a:solidFill>
+                        <a:srgbClr val="BFBFBF"/>
+                      </a:solidFill>
+                      <a:prstDash val="solid"/>
+                      <a:round/>
+                      <a:headEnd type="none" w="med" len="med"/>
+                      <a:tailEnd type="none" w="med" len="med"/>
+                    </a:lnB>
+                    <a:solidFill>
+                      <a:srgbClr val="FFFFFF"/>
+                    </a:solidFill>
+                  </a:tcPr>
+                </a:tc>
+              </a:tr>
+              <a:tr h="237744">
+                <a:tc>
+                  <a:txBody>
+                    <a:bodyPr/>
+                    <a:lstStyle/>
+                    <a:p>
+                      <a:pPr algn="l" indent="0" marL="0">
+                        <a:buNone/>
+                      </a:pPr>
+                      <a:r>
+                        <a:rPr lang="en-US" sz="800" dirty="0">
+                          <a:solidFill>
+                            <a:srgbClr val="1A1A1A"/>
+                          </a:solidFill>
+                          <a:latin typeface="Meiryo" pitchFamily="34" charset="0"/>
+                          <a:ea typeface="Meiryo" pitchFamily="34" charset="-122"/>
+                          <a:cs typeface="Meiryo" pitchFamily="34" charset="-120"/>
+                        </a:rPr>
+                        <a:t>月6時間は本当？</a:t>
+                      </a:r>
+                      <a:endParaRPr lang="en-US" sz="800" dirty="0">
+                        <a:latin typeface="Meiryo" charset="0"/>
+                        <a:ea typeface="Meiryo" charset="0"/>
+                        <a:cs typeface="Meiryo" charset="0"/>
+                      </a:endParaRPr>
+                    </a:p>
+                  </a:txBody>
+                  <a:tcPr marL="54864" marR="54864" marT="18288" marB="18288" anchor="ctr">
+                    <a:lnL w="0" cap="flat" cmpd="sng" algn="ctr">
+                      <a:noFill/>
+                    </a:lnL>
+                    <a:lnR w="0" cap="flat" cmpd="sng" algn="ctr">
+                      <a:noFill/>
+                    </a:lnR>
+                    <a:lnT w="0" cap="flat" cmpd="sng" algn="ctr">
+                      <a:noFill/>
+                    </a:lnT>
+                    <a:lnB w="9525" cap="flat" cmpd="sng" algn="ctr">
+                      <a:solidFill>
+                        <a:srgbClr val="BFBFBF"/>
+                      </a:solidFill>
+                      <a:prstDash val="solid"/>
+                      <a:round/>
+                      <a:headEnd type="none" w="med" len="med"/>
+                      <a:tailEnd type="none" w="med" len="med"/>
+                    </a:lnB>
+                    <a:solidFill>
+                      <a:srgbClr val="FFFFFF"/>
+                    </a:solidFill>
+                  </a:tcPr>
+                </a:tc>
+                <a:tc>
+                  <a:txBody>
+                    <a:bodyPr/>
+                    <a:lstStyle/>
+                    <a:p>
+                      <a:pPr algn="l" indent="0" marL="0">
+                        <a:buNone/>
+                      </a:pPr>
+                      <a:r>
+                        <a:rPr lang="en-US" sz="800" dirty="0">
+                          <a:solidFill>
+                            <a:srgbClr val="1A1A1A"/>
+                          </a:solidFill>
+                          <a:latin typeface="Meiryo" pitchFamily="34" charset="0"/>
+                          <a:ea typeface="Meiryo" pitchFamily="34" charset="-122"/>
+                          <a:cs typeface="Meiryo" pitchFamily="34" charset="-120"/>
+                        </a:rPr>
+                        <a:t>建設業の実績を準用した仮説です。500万円の実証で実測します</a:t>
+                      </a:r>
+                      <a:endParaRPr lang="en-US" sz="800" dirty="0">
+                        <a:latin typeface="Meiryo" charset="0"/>
+                        <a:ea typeface="Meiryo" charset="0"/>
+                        <a:cs typeface="Meiryo" charset="0"/>
+                      </a:endParaRPr>
+                    </a:p>
+                  </a:txBody>
+                  <a:tcPr marL="54864" marR="54864" marT="18288" marB="18288" anchor="ctr">
+                    <a:lnL w="0" cap="flat" cmpd="sng" algn="ctr">
+                      <a:noFill/>
+                    </a:lnL>
+                    <a:lnR w="0" cap="flat" cmpd="sng" algn="ctr">
+                      <a:noFill/>
+                    </a:lnR>
+                    <a:lnT w="0" cap="flat" cmpd="sng" algn="ctr">
+                      <a:noFill/>
+                    </a:lnT>
+                    <a:lnB w="9525" cap="flat" cmpd="sng" algn="ctr">
+                      <a:solidFill>
+                        <a:srgbClr val="BFBFBF"/>
+                      </a:solidFill>
+                      <a:prstDash val="solid"/>
+                      <a:round/>
+                      <a:headEnd type="none" w="med" len="med"/>
+                      <a:tailEnd type="none" w="med" len="med"/>
+                    </a:lnB>
+                    <a:solidFill>
+                      <a:srgbClr val="FFFFFF"/>
+                    </a:solidFill>
+                  </a:tcPr>
+                </a:tc>
+                <a:tc>
+                  <a:txBody>
+                    <a:bodyPr/>
+                    <a:lstStyle/>
+                    <a:p>
+                      <a:pPr algn="ctr" indent="0" marL="0">
+                        <a:buNone/>
+                      </a:pPr>
+                      <a:r>
+                        <a:rPr lang="en-US" sz="800" dirty="0">
+                          <a:solidFill>
+                            <a:srgbClr val="1A1A1A"/>
+                          </a:solidFill>
+                          <a:latin typeface="Meiryo" pitchFamily="34" charset="0"/>
+                          <a:ea typeface="Meiryo" pitchFamily="34" charset="-122"/>
+                          <a:cs typeface="Meiryo" pitchFamily="34" charset="-120"/>
+                        </a:rPr>
+                        <a:t>根拠2</a:t>
+                      </a:r>
+                      <a:endParaRPr lang="en-US" sz="800" dirty="0">
+                        <a:latin typeface="Meiryo" charset="0"/>
+                        <a:ea typeface="Meiryo" charset="0"/>
+                        <a:cs typeface="Meiryo" charset="0"/>
+                      </a:endParaRPr>
+                    </a:p>
+                  </a:txBody>
+                  <a:tcPr marL="54864" marR="54864" marT="18288" marB="18288" anchor="ctr">
+                    <a:lnL w="0" cap="flat" cmpd="sng" algn="ctr">
+                      <a:noFill/>
+                    </a:lnL>
+                    <a:lnR w="0" cap="flat" cmpd="sng" algn="ctr">
+                      <a:noFill/>
+                    </a:lnR>
+                    <a:lnT w="0" cap="flat" cmpd="sng" algn="ctr">
+                      <a:noFill/>
+                    </a:lnT>
+                    <a:lnB w="9525" cap="flat" cmpd="sng" algn="ctr">
+                      <a:solidFill>
+                        <a:srgbClr val="BFBFBF"/>
+                      </a:solidFill>
+                      <a:prstDash val="solid"/>
+                      <a:round/>
+                      <a:headEnd type="none" w="med" len="med"/>
+                      <a:tailEnd type="none" w="med" len="med"/>
+                    </a:lnB>
+                    <a:solidFill>
+                      <a:srgbClr val="FFFFFF"/>
+                    </a:solidFill>
+                  </a:tcPr>
+                </a:tc>
+              </a:tr>
+              <a:tr h="237744">
+                <a:tc>
+                  <a:txBody>
+                    <a:bodyPr/>
+                    <a:lstStyle/>
+                    <a:p>
+                      <a:pPr algn="l" indent="0" marL="0">
+                        <a:buNone/>
+                      </a:pPr>
+                      <a:r>
+                        <a:rPr lang="en-US" sz="800" dirty="0">
+                          <a:solidFill>
+                            <a:srgbClr val="1A1A1A"/>
+                          </a:solidFill>
+                          <a:latin typeface="Meiryo" pitchFamily="34" charset="0"/>
+                          <a:ea typeface="Meiryo" pitchFamily="34" charset="-122"/>
+                          <a:cs typeface="Meiryo" pitchFamily="34" charset="-120"/>
+                        </a:rPr>
+                        <a:t>なぜ電気工事から？</a:t>
+                      </a:r>
+                      <a:endParaRPr lang="en-US" sz="800" dirty="0">
+                        <a:latin typeface="Meiryo" charset="0"/>
+                        <a:ea typeface="Meiryo" charset="0"/>
+                        <a:cs typeface="Meiryo" charset="0"/>
+                      </a:endParaRPr>
+                    </a:p>
+                  </a:txBody>
+                  <a:tcPr marL="54864" marR="54864" marT="18288" marB="18288" anchor="ctr">
+                    <a:lnL w="0" cap="flat" cmpd="sng" algn="ctr">
+                      <a:noFill/>
+                    </a:lnL>
+                    <a:lnR w="0" cap="flat" cmpd="sng" algn="ctr">
+                      <a:noFill/>
+                    </a:lnR>
+                    <a:lnT w="0" cap="flat" cmpd="sng" algn="ctr">
+                      <a:noFill/>
+                    </a:lnT>
+                    <a:lnB w="9525" cap="flat" cmpd="sng" algn="ctr">
+                      <a:solidFill>
+                        <a:srgbClr val="BFBFBF"/>
+                      </a:solidFill>
+                      <a:prstDash val="solid"/>
+                      <a:round/>
+                      <a:headEnd type="none" w="med" len="med"/>
+                      <a:tailEnd type="none" w="med" len="med"/>
+                    </a:lnB>
+                    <a:solidFill>
+                      <a:srgbClr val="FFFFFF"/>
+                    </a:solidFill>
+                  </a:tcPr>
+                </a:tc>
+                <a:tc>
+                  <a:txBody>
+                    <a:bodyPr/>
+                    <a:lstStyle/>
+                    <a:p>
+                      <a:pPr algn="l" indent="0" marL="0">
+                        <a:buNone/>
+                      </a:pPr>
+                      <a:r>
+                        <a:rPr lang="en-US" sz="800" dirty="0">
+                          <a:solidFill>
+                            <a:srgbClr val="1A1A1A"/>
+                          </a:solidFill>
+                          <a:latin typeface="Meiryo" pitchFamily="34" charset="0"/>
+                          <a:ea typeface="Meiryo" pitchFamily="34" charset="-122"/>
+                          <a:cs typeface="Meiryo" pitchFamily="34" charset="-120"/>
+                        </a:rPr>
+                        <a:t>市場が最も大きく、残業規制で困りごとが強く、私の経歴が信用になるからです</a:t>
+                      </a:r>
+                      <a:endParaRPr lang="en-US" sz="800" dirty="0">
+                        <a:latin typeface="Meiryo" charset="0"/>
+                        <a:ea typeface="Meiryo" charset="0"/>
+                        <a:cs typeface="Meiryo" charset="0"/>
+                      </a:endParaRPr>
+                    </a:p>
+                  </a:txBody>
+                  <a:tcPr marL="54864" marR="54864" marT="18288" marB="18288" anchor="ctr">
+                    <a:lnL w="0" cap="flat" cmpd="sng" algn="ctr">
+                      <a:noFill/>
+                    </a:lnL>
+                    <a:lnR w="0" cap="flat" cmpd="sng" algn="ctr">
+                      <a:noFill/>
+                    </a:lnR>
+                    <a:lnT w="0" cap="flat" cmpd="sng" algn="ctr">
+                      <a:noFill/>
+                    </a:lnT>
+                    <a:lnB w="9525" cap="flat" cmpd="sng" algn="ctr">
+                      <a:solidFill>
+                        <a:srgbClr val="BFBFBF"/>
+                      </a:solidFill>
+                      <a:prstDash val="solid"/>
+                      <a:round/>
+                      <a:headEnd type="none" w="med" len="med"/>
+                      <a:tailEnd type="none" w="med" len="med"/>
+                    </a:lnB>
+                    <a:solidFill>
+                      <a:srgbClr val="FFFFFF"/>
+                    </a:solidFill>
+                  </a:tcPr>
+                </a:tc>
+                <a:tc>
+                  <a:txBody>
+                    <a:bodyPr/>
+                    <a:lstStyle/>
+                    <a:p>
+                      <a:pPr algn="ctr" indent="0" marL="0">
+                        <a:buNone/>
+                      </a:pPr>
+                      <a:r>
+                        <a:rPr lang="en-US" sz="800" dirty="0">
+                          <a:solidFill>
+                            <a:srgbClr val="1A1A1A"/>
+                          </a:solidFill>
+                          <a:latin typeface="Meiryo" pitchFamily="34" charset="0"/>
+                          <a:ea typeface="Meiryo" pitchFamily="34" charset="-122"/>
+                          <a:cs typeface="Meiryo" pitchFamily="34" charset="-120"/>
+                        </a:rPr>
+                        <a:t>根拠12</a:t>
+                      </a:r>
+                      <a:endParaRPr lang="en-US" sz="800" dirty="0">
+                        <a:latin typeface="Meiryo" charset="0"/>
+                        <a:ea typeface="Meiryo" charset="0"/>
+                        <a:cs typeface="Meiryo" charset="0"/>
+                      </a:endParaRPr>
+                    </a:p>
+                  </a:txBody>
+                  <a:tcPr marL="54864" marR="54864" marT="18288" marB="18288" anchor="ctr">
+                    <a:lnL w="0" cap="flat" cmpd="sng" algn="ctr">
+                      <a:noFill/>
+                    </a:lnL>
+                    <a:lnR w="0" cap="flat" cmpd="sng" algn="ctr">
+                      <a:noFill/>
+                    </a:lnR>
+                    <a:lnT w="0" cap="flat" cmpd="sng" algn="ctr">
+                      <a:noFill/>
+                    </a:lnT>
+                    <a:lnB w="9525" cap="flat" cmpd="sng" algn="ctr">
+                      <a:solidFill>
+                        <a:srgbClr val="BFBFBF"/>
+                      </a:solidFill>
+                      <a:prstDash val="solid"/>
+                      <a:round/>
+                      <a:headEnd type="none" w="med" len="med"/>
+                      <a:tailEnd type="none" w="med" len="med"/>
+                    </a:lnB>
+                    <a:solidFill>
+                      <a:srgbClr val="FFFFFF"/>
+                    </a:solidFill>
+                  </a:tcPr>
+                </a:tc>
+              </a:tr>
+              <a:tr h="237744">
+                <a:tc>
+                  <a:txBody>
+                    <a:bodyPr/>
+                    <a:lstStyle/>
+                    <a:p>
+                      <a:pPr algn="l" indent="0" marL="0">
+                        <a:buNone/>
+                      </a:pPr>
+                      <a:r>
+                        <a:rPr lang="en-US" sz="800" dirty="0">
+                          <a:solidFill>
+                            <a:srgbClr val="1A1A1A"/>
+                          </a:solidFill>
+                          <a:latin typeface="Meiryo" pitchFamily="34" charset="0"/>
+                          <a:ea typeface="Meiryo" pitchFamily="34" charset="-122"/>
+                          <a:cs typeface="Meiryo" pitchFamily="34" charset="-120"/>
+                        </a:rPr>
+                        <a:t>ANDPADがあるのでは？</a:t>
+                      </a:r>
+                      <a:endParaRPr lang="en-US" sz="800" dirty="0">
+                        <a:latin typeface="Meiryo" charset="0"/>
+                        <a:ea typeface="Meiryo" charset="0"/>
+                        <a:cs typeface="Meiryo" charset="0"/>
+                      </a:endParaRPr>
+                    </a:p>
+                  </a:txBody>
+                  <a:tcPr marL="54864" marR="54864" marT="18288" marB="18288" anchor="ctr">
+                    <a:lnL w="0" cap="flat" cmpd="sng" algn="ctr">
+                      <a:noFill/>
+                    </a:lnL>
+                    <a:lnR w="0" cap="flat" cmpd="sng" algn="ctr">
+                      <a:noFill/>
+                    </a:lnR>
+                    <a:lnT w="0" cap="flat" cmpd="sng" algn="ctr">
+                      <a:noFill/>
+                    </a:lnT>
+                    <a:lnB w="9525" cap="flat" cmpd="sng" algn="ctr">
+                      <a:solidFill>
+                        <a:srgbClr val="BFBFBF"/>
+                      </a:solidFill>
+                      <a:prstDash val="solid"/>
+                      <a:round/>
+                      <a:headEnd type="none" w="med" len="med"/>
+                      <a:tailEnd type="none" w="med" len="med"/>
+                    </a:lnB>
+                    <a:solidFill>
+                      <a:srgbClr val="FFFFFF"/>
+                    </a:solidFill>
+                  </a:tcPr>
+                </a:tc>
+                <a:tc>
+                  <a:txBody>
+                    <a:bodyPr/>
+                    <a:lstStyle/>
+                    <a:p>
+                      <a:pPr algn="l" indent="0" marL="0">
+                        <a:buNone/>
+                      </a:pPr>
+                      <a:r>
+                        <a:rPr lang="en-US" sz="800" dirty="0">
+                          <a:solidFill>
+                            <a:srgbClr val="1A1A1A"/>
+                          </a:solidFill>
+                          <a:latin typeface="Meiryo" pitchFamily="34" charset="0"/>
+                          <a:ea typeface="Meiryo" pitchFamily="34" charset="-122"/>
+                          <a:cs typeface="Meiryo" pitchFamily="34" charset="-120"/>
+                        </a:rPr>
+                        <a:t>あれは人が入力する器。当社は自動で記録し判断を渡す。競わず連携します</a:t>
+                      </a:r>
+                      <a:endParaRPr lang="en-US" sz="800" dirty="0">
+                        <a:latin typeface="Meiryo" charset="0"/>
+                        <a:ea typeface="Meiryo" charset="0"/>
+                        <a:cs typeface="Meiryo" charset="0"/>
+                      </a:endParaRPr>
+                    </a:p>
+                  </a:txBody>
+                  <a:tcPr marL="54864" marR="54864" marT="18288" marB="18288" anchor="ctr">
+                    <a:lnL w="0" cap="flat" cmpd="sng" algn="ctr">
+                      <a:noFill/>
+                    </a:lnL>
+                    <a:lnR w="0" cap="flat" cmpd="sng" algn="ctr">
+                      <a:noFill/>
+                    </a:lnR>
+                    <a:lnT w="0" cap="flat" cmpd="sng" algn="ctr">
+                      <a:noFill/>
+                    </a:lnT>
+                    <a:lnB w="9525" cap="flat" cmpd="sng" algn="ctr">
+                      <a:solidFill>
+                        <a:srgbClr val="BFBFBF"/>
+                      </a:solidFill>
+                      <a:prstDash val="solid"/>
+                      <a:round/>
+                      <a:headEnd type="none" w="med" len="med"/>
+                      <a:tailEnd type="none" w="med" len="med"/>
+                    </a:lnB>
+                    <a:solidFill>
+                      <a:srgbClr val="FFFFFF"/>
+                    </a:solidFill>
+                  </a:tcPr>
+                </a:tc>
+                <a:tc>
+                  <a:txBody>
+                    <a:bodyPr/>
+                    <a:lstStyle/>
+                    <a:p>
+                      <a:pPr algn="ctr" indent="0" marL="0">
+                        <a:buNone/>
+                      </a:pPr>
+                      <a:r>
+                        <a:rPr lang="en-US" sz="800" dirty="0">
+                          <a:solidFill>
+                            <a:srgbClr val="1A1A1A"/>
+                          </a:solidFill>
+                          <a:latin typeface="Meiryo" pitchFamily="34" charset="0"/>
+                          <a:ea typeface="Meiryo" pitchFamily="34" charset="-122"/>
+                          <a:cs typeface="Meiryo" pitchFamily="34" charset="-120"/>
+                        </a:rPr>
+                        <a:t>発表資料③</a:t>
+                      </a:r>
+                      <a:endParaRPr lang="en-US" sz="800" dirty="0">
+                        <a:latin typeface="Meiryo" charset="0"/>
+                        <a:ea typeface="Meiryo" charset="0"/>
+                        <a:cs typeface="Meiryo" charset="0"/>
+                      </a:endParaRPr>
+                    </a:p>
+                  </a:txBody>
+                  <a:tcPr marL="54864" marR="54864" marT="18288" marB="18288" anchor="ctr">
+                    <a:lnL w="0" cap="flat" cmpd="sng" algn="ctr">
+                      <a:noFill/>
+                    </a:lnL>
+                    <a:lnR w="0" cap="flat" cmpd="sng" algn="ctr">
+                      <a:noFill/>
+                    </a:lnR>
+                    <a:lnT w="0" cap="flat" cmpd="sng" algn="ctr">
+                      <a:noFill/>
+                    </a:lnT>
+                    <a:lnB w="9525" cap="flat" cmpd="sng" algn="ctr">
+                      <a:solidFill>
+                        <a:srgbClr val="BFBFBF"/>
+                      </a:solidFill>
+                      <a:prstDash val="solid"/>
+                      <a:round/>
+                      <a:headEnd type="none" w="med" len="med"/>
+                      <a:tailEnd type="none" w="med" len="med"/>
+                    </a:lnB>
+                    <a:solidFill>
+                      <a:srgbClr val="FFFFFF"/>
+                    </a:solidFill>
+                  </a:tcPr>
+                </a:tc>
+              </a:tr>
+              <a:tr h="237744">
+                <a:tc>
+                  <a:txBody>
+                    <a:bodyPr/>
+                    <a:lstStyle/>
+                    <a:p>
+                      <a:pPr algn="l" indent="0" marL="0">
+                        <a:buNone/>
+                      </a:pPr>
+                      <a:r>
+                        <a:rPr lang="en-US" sz="800" dirty="0">
+                          <a:solidFill>
+                            <a:srgbClr val="1A1A1A"/>
+                          </a:solidFill>
+                          <a:latin typeface="Meiryo" pitchFamily="34" charset="0"/>
+                          <a:ea typeface="Meiryo" pitchFamily="34" charset="-122"/>
+                          <a:cs typeface="Meiryo" pitchFamily="34" charset="-120"/>
+                        </a:rPr>
+                        <a:t>なぜ4年目まで赤字？</a:t>
+                      </a:r>
+                      <a:endParaRPr lang="en-US" sz="800" dirty="0">
+                        <a:latin typeface="Meiryo" charset="0"/>
+                        <a:ea typeface="Meiryo" charset="0"/>
+                        <a:cs typeface="Meiryo" charset="0"/>
+                      </a:endParaRPr>
+                    </a:p>
+                  </a:txBody>
+                  <a:tcPr marL="54864" marR="54864" marT="18288" marB="18288" anchor="ctr">
+                    <a:lnL w="0" cap="flat" cmpd="sng" algn="ctr">
+                      <a:noFill/>
+                    </a:lnL>
+                    <a:lnR w="0" cap="flat" cmpd="sng" algn="ctr">
+                      <a:noFill/>
+                    </a:lnR>
+                    <a:lnT w="0" cap="flat" cmpd="sng" algn="ctr">
+                      <a:noFill/>
+                    </a:lnT>
+                    <a:lnB w="9525" cap="flat" cmpd="sng" algn="ctr">
+                      <a:solidFill>
+                        <a:srgbClr val="BFBFBF"/>
+                      </a:solidFill>
+                      <a:prstDash val="solid"/>
+                      <a:round/>
+                      <a:headEnd type="none" w="med" len="med"/>
+                      <a:tailEnd type="none" w="med" len="med"/>
+                    </a:lnB>
+                    <a:solidFill>
+                      <a:srgbClr val="FFFFFF"/>
+                    </a:solidFill>
+                  </a:tcPr>
+                </a:tc>
+                <a:tc>
+                  <a:txBody>
+                    <a:bodyPr/>
+                    <a:lstStyle/>
+                    <a:p>
+                      <a:pPr algn="l" indent="0" marL="0">
+                        <a:buNone/>
+                      </a:pPr>
+                      <a:r>
+                        <a:rPr lang="en-US" sz="800" dirty="0">
+                          <a:solidFill>
+                            <a:srgbClr val="1A1A1A"/>
+                          </a:solidFill>
+                          <a:latin typeface="Meiryo" pitchFamily="34" charset="0"/>
+                          <a:ea typeface="Meiryo" pitchFamily="34" charset="-122"/>
+                          <a:cs typeface="Meiryo" pitchFamily="34" charset="-120"/>
+                        </a:rPr>
+                        <a:t>人を先に雇うからです。1人2.8拠点を超える4年目に黒字</a:t>
+                      </a:r>
+                      <a:endParaRPr lang="en-US" sz="800" dirty="0">
+                        <a:latin typeface="Meiryo" charset="0"/>
+                        <a:ea typeface="Meiryo" charset="0"/>
+                        <a:cs typeface="Meiryo" charset="0"/>
+                      </a:endParaRPr>
+                    </a:p>
+                  </a:txBody>
+                  <a:tcPr marL="54864" marR="54864" marT="18288" marB="18288" anchor="ctr">
+                    <a:lnL w="0" cap="flat" cmpd="sng" algn="ctr">
+                      <a:noFill/>
+                    </a:lnL>
+                    <a:lnR w="0" cap="flat" cmpd="sng" algn="ctr">
+                      <a:noFill/>
+                    </a:lnR>
+                    <a:lnT w="0" cap="flat" cmpd="sng" algn="ctr">
+                      <a:noFill/>
+                    </a:lnT>
+                    <a:lnB w="9525" cap="flat" cmpd="sng" algn="ctr">
+                      <a:solidFill>
+                        <a:srgbClr val="BFBFBF"/>
+                      </a:solidFill>
+                      <a:prstDash val="solid"/>
+                      <a:round/>
+                      <a:headEnd type="none" w="med" len="med"/>
+                      <a:tailEnd type="none" w="med" len="med"/>
+                    </a:lnB>
+                    <a:solidFill>
+                      <a:srgbClr val="FFFFFF"/>
+                    </a:solidFill>
+                  </a:tcPr>
+                </a:tc>
+                <a:tc>
+                  <a:txBody>
+                    <a:bodyPr/>
+                    <a:lstStyle/>
+                    <a:p>
+                      <a:pPr algn="ctr" indent="0" marL="0">
+                        <a:buNone/>
+                      </a:pPr>
+                      <a:r>
+                        <a:rPr lang="en-US" sz="800" dirty="0">
+                          <a:solidFill>
+                            <a:srgbClr val="1A1A1A"/>
+                          </a:solidFill>
+                          <a:latin typeface="Meiryo" pitchFamily="34" charset="0"/>
+                          <a:ea typeface="Meiryo" pitchFamily="34" charset="-122"/>
+                          <a:cs typeface="Meiryo" pitchFamily="34" charset="-120"/>
+                        </a:rPr>
+                        <a:t>根拠7</a:t>
+                      </a:r>
+                      <a:endParaRPr lang="en-US" sz="800" dirty="0">
+                        <a:latin typeface="Meiryo" charset="0"/>
+                        <a:ea typeface="Meiryo" charset="0"/>
+                        <a:cs typeface="Meiryo" charset="0"/>
+                      </a:endParaRPr>
+                    </a:p>
+                  </a:txBody>
+                  <a:tcPr marL="54864" marR="54864" marT="18288" marB="18288" anchor="ctr">
+                    <a:lnL w="0" cap="flat" cmpd="sng" algn="ctr">
+                      <a:noFill/>
+                    </a:lnL>
+                    <a:lnR w="0" cap="flat" cmpd="sng" algn="ctr">
+                      <a:noFill/>
+                    </a:lnR>
+                    <a:lnT w="0" cap="flat" cmpd="sng" algn="ctr">
+                      <a:noFill/>
+                    </a:lnT>
+                    <a:lnB w="9525" cap="flat" cmpd="sng" algn="ctr">
+                      <a:solidFill>
+                        <a:srgbClr val="BFBFBF"/>
+                      </a:solidFill>
+                      <a:prstDash val="solid"/>
+                      <a:round/>
+                      <a:headEnd type="none" w="med" len="med"/>
+                      <a:tailEnd type="none" w="med" len="med"/>
+                    </a:lnB>
+                    <a:solidFill>
+                      <a:srgbClr val="FFFFFF"/>
+                    </a:solidFill>
+                  </a:tcPr>
+                </a:tc>
+              </a:tr>
+              <a:tr h="237744">
+                <a:tc>
+                  <a:txBody>
+                    <a:bodyPr/>
+                    <a:lstStyle/>
+                    <a:p>
+                      <a:pPr algn="l" indent="0" marL="0">
+                        <a:buNone/>
+                      </a:pPr>
+                      <a:r>
+                        <a:rPr lang="en-US" sz="800" dirty="0">
+                          <a:solidFill>
+                            <a:srgbClr val="1A1A1A"/>
+                          </a:solidFill>
+                          <a:latin typeface="Meiryo" pitchFamily="34" charset="0"/>
+                          <a:ea typeface="Meiryo" pitchFamily="34" charset="-122"/>
+                          <a:cs typeface="Meiryo" pitchFamily="34" charset="-120"/>
+                        </a:rPr>
+                        <a:t>獲得が遅れたら？</a:t>
+                      </a:r>
+                      <a:endParaRPr lang="en-US" sz="800" dirty="0">
+                        <a:latin typeface="Meiryo" charset="0"/>
+                        <a:ea typeface="Meiryo" charset="0"/>
+                        <a:cs typeface="Meiryo" charset="0"/>
+                      </a:endParaRPr>
+                    </a:p>
+                  </a:txBody>
+                  <a:tcPr marL="54864" marR="54864" marT="18288" marB="18288" anchor="ctr">
+                    <a:lnL w="0" cap="flat" cmpd="sng" algn="ctr">
+                      <a:noFill/>
+                    </a:lnL>
+                    <a:lnR w="0" cap="flat" cmpd="sng" algn="ctr">
+                      <a:noFill/>
+                    </a:lnR>
+                    <a:lnT w="0" cap="flat" cmpd="sng" algn="ctr">
+                      <a:noFill/>
+                    </a:lnT>
+                    <a:lnB w="9525" cap="flat" cmpd="sng" algn="ctr">
+                      <a:solidFill>
+                        <a:srgbClr val="BFBFBF"/>
+                      </a:solidFill>
+                      <a:prstDash val="solid"/>
+                      <a:round/>
+                      <a:headEnd type="none" w="med" len="med"/>
+                      <a:tailEnd type="none" w="med" len="med"/>
+                    </a:lnB>
+                    <a:solidFill>
+                      <a:srgbClr val="FFFFFF"/>
+                    </a:solidFill>
+                  </a:tcPr>
+                </a:tc>
+                <a:tc>
+                  <a:txBody>
+                    <a:bodyPr/>
+                    <a:lstStyle/>
+                    <a:p>
+                      <a:pPr algn="l" indent="0" marL="0">
+                        <a:buNone/>
+                      </a:pPr>
+                      <a:r>
+                        <a:rPr lang="en-US" sz="800" dirty="0">
+                          <a:solidFill>
+                            <a:srgbClr val="1A1A1A"/>
+                          </a:solidFill>
+                          <a:latin typeface="Meiryo" pitchFamily="34" charset="0"/>
+                          <a:ea typeface="Meiryo" pitchFamily="34" charset="-122"/>
+                          <a:cs typeface="Meiryo" pitchFamily="34" charset="-120"/>
+                        </a:rPr>
+                        <a:t>採用も遅らせます。3割遅れても現金は2,000万円を割りません</a:t>
+                      </a:r>
+                      <a:endParaRPr lang="en-US" sz="800" dirty="0">
+                        <a:latin typeface="Meiryo" charset="0"/>
+                        <a:ea typeface="Meiryo" charset="0"/>
+                        <a:cs typeface="Meiryo" charset="0"/>
+                      </a:endParaRPr>
+                    </a:p>
+                  </a:txBody>
+                  <a:tcPr marL="54864" marR="54864" marT="18288" marB="18288" anchor="ctr">
+                    <a:lnL w="0" cap="flat" cmpd="sng" algn="ctr">
+                      <a:noFill/>
+                    </a:lnL>
+                    <a:lnR w="0" cap="flat" cmpd="sng" algn="ctr">
+                      <a:noFill/>
+                    </a:lnR>
+                    <a:lnT w="0" cap="flat" cmpd="sng" algn="ctr">
+                      <a:noFill/>
+                    </a:lnT>
+                    <a:lnB w="9525" cap="flat" cmpd="sng" algn="ctr">
+                      <a:solidFill>
+                        <a:srgbClr val="BFBFBF"/>
+                      </a:solidFill>
+                      <a:prstDash val="solid"/>
+                      <a:round/>
+                      <a:headEnd type="none" w="med" len="med"/>
+                      <a:tailEnd type="none" w="med" len="med"/>
+                    </a:lnB>
+                    <a:solidFill>
+                      <a:srgbClr val="FFFFFF"/>
+                    </a:solidFill>
+                  </a:tcPr>
+                </a:tc>
+                <a:tc>
+                  <a:txBody>
+                    <a:bodyPr/>
+                    <a:lstStyle/>
+                    <a:p>
+                      <a:pPr algn="ctr" indent="0" marL="0">
+                        <a:buNone/>
+                      </a:pPr>
+                      <a:r>
+                        <a:rPr lang="en-US" sz="800" dirty="0">
+                          <a:solidFill>
+                            <a:srgbClr val="1A1A1A"/>
+                          </a:solidFill>
+                          <a:latin typeface="Meiryo" pitchFamily="34" charset="0"/>
+                          <a:ea typeface="Meiryo" pitchFamily="34" charset="-122"/>
+                          <a:cs typeface="Meiryo" pitchFamily="34" charset="-120"/>
+                        </a:rPr>
+                        <a:t>根拠9</a:t>
+                      </a:r>
+                      <a:endParaRPr lang="en-US" sz="800" dirty="0">
+                        <a:latin typeface="Meiryo" charset="0"/>
+                        <a:ea typeface="Meiryo" charset="0"/>
+                        <a:cs typeface="Meiryo" charset="0"/>
+                      </a:endParaRPr>
+                    </a:p>
+                  </a:txBody>
+                  <a:tcPr marL="54864" marR="54864" marT="18288" marB="18288" anchor="ctr">
+                    <a:lnL w="0" cap="flat" cmpd="sng" algn="ctr">
+                      <a:noFill/>
+                    </a:lnL>
+                    <a:lnR w="0" cap="flat" cmpd="sng" algn="ctr">
+                      <a:noFill/>
+                    </a:lnR>
+                    <a:lnT w="0" cap="flat" cmpd="sng" algn="ctr">
+                      <a:noFill/>
+                    </a:lnT>
+                    <a:lnB w="9525" cap="flat" cmpd="sng" algn="ctr">
+                      <a:solidFill>
+                        <a:srgbClr val="BFBFBF"/>
+                      </a:solidFill>
+                      <a:prstDash val="solid"/>
+                      <a:round/>
+                      <a:headEnd type="none" w="med" len="med"/>
+                      <a:tailEnd type="none" w="med" len="med"/>
+                    </a:lnB>
+                    <a:solidFill>
+                      <a:srgbClr val="FFFFFF"/>
+                    </a:solidFill>
+                  </a:tcPr>
+                </a:tc>
+              </a:tr>
+              <a:tr h="237744">
+                <a:tc>
+                  <a:txBody>
+                    <a:bodyPr/>
+                    <a:lstStyle/>
+                    <a:p>
+                      <a:pPr algn="l" indent="0" marL="0">
+                        <a:buNone/>
+                      </a:pPr>
+                      <a:r>
+                        <a:rPr lang="en-US" sz="800" dirty="0">
+                          <a:solidFill>
+                            <a:srgbClr val="1A1A1A"/>
+                          </a:solidFill>
+                          <a:latin typeface="Meiryo" pitchFamily="34" charset="0"/>
+                          <a:ea typeface="Meiryo" pitchFamily="34" charset="-122"/>
+                          <a:cs typeface="Meiryo" pitchFamily="34" charset="-120"/>
+                        </a:rPr>
+                        <a:t>値引きされたら？</a:t>
+                      </a:r>
+                      <a:endParaRPr lang="en-US" sz="800" dirty="0">
+                        <a:latin typeface="Meiryo" charset="0"/>
+                        <a:ea typeface="Meiryo" charset="0"/>
+                        <a:cs typeface="Meiryo" charset="0"/>
+                      </a:endParaRPr>
+                    </a:p>
+                  </a:txBody>
+                  <a:tcPr marL="54864" marR="54864" marT="18288" marB="18288" anchor="ctr">
+                    <a:lnL w="0" cap="flat" cmpd="sng" algn="ctr">
+                      <a:noFill/>
+                    </a:lnL>
+                    <a:lnR w="0" cap="flat" cmpd="sng" algn="ctr">
+                      <a:noFill/>
+                    </a:lnR>
+                    <a:lnT w="0" cap="flat" cmpd="sng" algn="ctr">
+                      <a:noFill/>
+                    </a:lnT>
+                    <a:lnB w="9525" cap="flat" cmpd="sng" algn="ctr">
+                      <a:solidFill>
+                        <a:srgbClr val="BFBFBF"/>
+                      </a:solidFill>
+                      <a:prstDash val="solid"/>
+                      <a:round/>
+                      <a:headEnd type="none" w="med" len="med"/>
+                      <a:tailEnd type="none" w="med" len="med"/>
+                    </a:lnB>
+                    <a:solidFill>
+                      <a:srgbClr val="FFFFFF"/>
+                    </a:solidFill>
+                  </a:tcPr>
+                </a:tc>
+                <a:tc>
+                  <a:txBody>
+                    <a:bodyPr/>
+                    <a:lstStyle/>
+                    <a:p>
+                      <a:pPr algn="l" indent="0" marL="0">
+                        <a:buNone/>
+                      </a:pPr>
+                      <a:r>
+                        <a:rPr lang="en-US" sz="800" dirty="0">
+                          <a:solidFill>
+                            <a:srgbClr val="1A1A1A"/>
+                          </a:solidFill>
+                          <a:latin typeface="Meiryo" pitchFamily="34" charset="0"/>
+                          <a:ea typeface="Meiryo" pitchFamily="34" charset="-122"/>
+                          <a:cs typeface="Meiryo" pitchFamily="34" charset="-120"/>
+                        </a:rPr>
+                        <a:t>2割引きでも4年目に黒字。5年目の営業利益は3,200万円</a:t>
+                      </a:r>
+                      <a:endParaRPr lang="en-US" sz="800" dirty="0">
+                        <a:latin typeface="Meiryo" charset="0"/>
+                        <a:ea typeface="Meiryo" charset="0"/>
+                        <a:cs typeface="Meiryo" charset="0"/>
+                      </a:endParaRPr>
+                    </a:p>
+                  </a:txBody>
+                  <a:tcPr marL="54864" marR="54864" marT="18288" marB="18288" anchor="ctr">
+                    <a:lnL w="0" cap="flat" cmpd="sng" algn="ctr">
+                      <a:noFill/>
+                    </a:lnL>
+                    <a:lnR w="0" cap="flat" cmpd="sng" algn="ctr">
+                      <a:noFill/>
+                    </a:lnR>
+                    <a:lnT w="0" cap="flat" cmpd="sng" algn="ctr">
+                      <a:noFill/>
+                    </a:lnT>
+                    <a:lnB w="9525" cap="flat" cmpd="sng" algn="ctr">
+                      <a:solidFill>
+                        <a:srgbClr val="BFBFBF"/>
+                      </a:solidFill>
+                      <a:prstDash val="solid"/>
+                      <a:round/>
+                      <a:headEnd type="none" w="med" len="med"/>
+                      <a:tailEnd type="none" w="med" len="med"/>
+                    </a:lnB>
+                    <a:solidFill>
+                      <a:srgbClr val="FFFFFF"/>
+                    </a:solidFill>
+                  </a:tcPr>
+                </a:tc>
+                <a:tc>
+                  <a:txBody>
+                    <a:bodyPr/>
+                    <a:lstStyle/>
+                    <a:p>
+                      <a:pPr algn="ctr" indent="0" marL="0">
+                        <a:buNone/>
+                      </a:pPr>
+                      <a:r>
+                        <a:rPr lang="en-US" sz="800" dirty="0">
+                          <a:solidFill>
+                            <a:srgbClr val="1A1A1A"/>
+                          </a:solidFill>
+                          <a:latin typeface="Meiryo" pitchFamily="34" charset="0"/>
+                          <a:ea typeface="Meiryo" pitchFamily="34" charset="-122"/>
+                          <a:cs typeface="Meiryo" pitchFamily="34" charset="-120"/>
+                        </a:rPr>
+                        <a:t>根拠9</a:t>
+                      </a:r>
+                      <a:endParaRPr lang="en-US" sz="800" dirty="0">
+                        <a:latin typeface="Meiryo" charset="0"/>
+                        <a:ea typeface="Meiryo" charset="0"/>
+                        <a:cs typeface="Meiryo" charset="0"/>
+                      </a:endParaRPr>
+                    </a:p>
+                  </a:txBody>
+                  <a:tcPr marL="54864" marR="54864" marT="18288" marB="18288" anchor="ctr">
+                    <a:lnL w="0" cap="flat" cmpd="sng" algn="ctr">
+                      <a:noFill/>
+                    </a:lnL>
+                    <a:lnR w="0" cap="flat" cmpd="sng" algn="ctr">
+                      <a:noFill/>
+                    </a:lnR>
+                    <a:lnT w="0" cap="flat" cmpd="sng" algn="ctr">
+                      <a:noFill/>
+                    </a:lnT>
+                    <a:lnB w="9525" cap="flat" cmpd="sng" algn="ctr">
+                      <a:solidFill>
+                        <a:srgbClr val="BFBFBF"/>
+                      </a:solidFill>
+                      <a:prstDash val="solid"/>
+                      <a:round/>
+                      <a:headEnd type="none" w="med" len="med"/>
+                      <a:tailEnd type="none" w="med" len="med"/>
+                    </a:lnB>
+                    <a:solidFill>
+                      <a:srgbClr val="FFFFFF"/>
+                    </a:solidFill>
+                  </a:tcPr>
+                </a:tc>
+              </a:tr>
+              <a:tr h="237744">
+                <a:tc>
+                  <a:txBody>
+                    <a:bodyPr/>
+                    <a:lstStyle/>
+                    <a:p>
+                      <a:pPr algn="l" indent="0" marL="0">
+                        <a:buNone/>
+                      </a:pPr>
+                      <a:r>
+                        <a:rPr lang="en-US" sz="800" dirty="0">
+                          <a:solidFill>
+                            <a:srgbClr val="1A1A1A"/>
+                          </a:solidFill>
+                          <a:latin typeface="Meiryo" pitchFamily="34" charset="0"/>
+                          <a:ea typeface="Meiryo" pitchFamily="34" charset="-122"/>
+                          <a:cs typeface="Meiryo" pitchFamily="34" charset="-120"/>
+                        </a:rPr>
+                        <a:t>LTV 7年は甘くない？</a:t>
+                      </a:r>
+                      <a:endParaRPr lang="en-US" sz="800" dirty="0">
+                        <a:latin typeface="Meiryo" charset="0"/>
+                        <a:ea typeface="Meiryo" charset="0"/>
+                        <a:cs typeface="Meiryo" charset="0"/>
+                      </a:endParaRPr>
+                    </a:p>
+                  </a:txBody>
+                  <a:tcPr marL="54864" marR="54864" marT="18288" marB="18288" anchor="ctr">
+                    <a:lnL w="0" cap="flat" cmpd="sng" algn="ctr">
+                      <a:noFill/>
+                    </a:lnL>
+                    <a:lnR w="0" cap="flat" cmpd="sng" algn="ctr">
+                      <a:noFill/>
+                    </a:lnR>
+                    <a:lnT w="0" cap="flat" cmpd="sng" algn="ctr">
+                      <a:noFill/>
+                    </a:lnT>
+                    <a:lnB w="9525" cap="flat" cmpd="sng" algn="ctr">
+                      <a:solidFill>
+                        <a:srgbClr val="BFBFBF"/>
+                      </a:solidFill>
+                      <a:prstDash val="solid"/>
+                      <a:round/>
+                      <a:headEnd type="none" w="med" len="med"/>
+                      <a:tailEnd type="none" w="med" len="med"/>
+                    </a:lnB>
+                    <a:solidFill>
+                      <a:srgbClr val="FFFFFF"/>
+                    </a:solidFill>
+                  </a:tcPr>
+                </a:tc>
+                <a:tc>
+                  <a:txBody>
+                    <a:bodyPr/>
+                    <a:lstStyle/>
+                    <a:p>
+                      <a:pPr algn="l" indent="0" marL="0">
+                        <a:buNone/>
+                      </a:pPr>
+                      <a:r>
+                        <a:rPr lang="en-US" sz="800" dirty="0">
+                          <a:solidFill>
+                            <a:srgbClr val="1A1A1A"/>
+                          </a:solidFill>
+                          <a:latin typeface="Meiryo" pitchFamily="34" charset="0"/>
+                          <a:ea typeface="Meiryo" pitchFamily="34" charset="-122"/>
+                          <a:cs typeface="Meiryo" pitchFamily="34" charset="-120"/>
+                        </a:rPr>
+                        <a:t>計画の解約率なら平均18年。3年でもCACの13倍です</a:t>
+                      </a:r>
+                      <a:endParaRPr lang="en-US" sz="800" dirty="0">
+                        <a:latin typeface="Meiryo" charset="0"/>
+                        <a:ea typeface="Meiryo" charset="0"/>
+                        <a:cs typeface="Meiryo" charset="0"/>
+                      </a:endParaRPr>
+                    </a:p>
+                  </a:txBody>
+                  <a:tcPr marL="54864" marR="54864" marT="18288" marB="18288" anchor="ctr">
+                    <a:lnL w="0" cap="flat" cmpd="sng" algn="ctr">
+                      <a:noFill/>
+                    </a:lnL>
+                    <a:lnR w="0" cap="flat" cmpd="sng" algn="ctr">
+                      <a:noFill/>
+                    </a:lnR>
+                    <a:lnT w="0" cap="flat" cmpd="sng" algn="ctr">
+                      <a:noFill/>
+                    </a:lnT>
+                    <a:lnB w="9525" cap="flat" cmpd="sng" algn="ctr">
+                      <a:solidFill>
+                        <a:srgbClr val="BFBFBF"/>
+                      </a:solidFill>
+                      <a:prstDash val="solid"/>
+                      <a:round/>
+                      <a:headEnd type="none" w="med" len="med"/>
+                      <a:tailEnd type="none" w="med" len="med"/>
+                    </a:lnB>
+                    <a:solidFill>
+                      <a:srgbClr val="FFFFFF"/>
+                    </a:solidFill>
+                  </a:tcPr>
+                </a:tc>
+                <a:tc>
+                  <a:txBody>
+                    <a:bodyPr/>
+                    <a:lstStyle/>
+                    <a:p>
+                      <a:pPr algn="ctr" indent="0" marL="0">
+                        <a:buNone/>
+                      </a:pPr>
+                      <a:r>
+                        <a:rPr lang="en-US" sz="800" dirty="0">
+                          <a:solidFill>
+                            <a:srgbClr val="1A1A1A"/>
+                          </a:solidFill>
+                          <a:latin typeface="Meiryo" pitchFamily="34" charset="0"/>
+                          <a:ea typeface="Meiryo" pitchFamily="34" charset="-122"/>
+                          <a:cs typeface="Meiryo" pitchFamily="34" charset="-120"/>
+                        </a:rPr>
+                        <a:t>根拠8</a:t>
+                      </a:r>
+                      <a:endParaRPr lang="en-US" sz="800" dirty="0">
+                        <a:latin typeface="Meiryo" charset="0"/>
+                        <a:ea typeface="Meiryo" charset="0"/>
+                        <a:cs typeface="Meiryo" charset="0"/>
+                      </a:endParaRPr>
+                    </a:p>
+                  </a:txBody>
+                  <a:tcPr marL="54864" marR="54864" marT="18288" marB="18288" anchor="ctr">
+                    <a:lnL w="0" cap="flat" cmpd="sng" algn="ctr">
+                      <a:noFill/>
+                    </a:lnL>
+                    <a:lnR w="0" cap="flat" cmpd="sng" algn="ctr">
+                      <a:noFill/>
+                    </a:lnR>
+                    <a:lnT w="0" cap="flat" cmpd="sng" algn="ctr">
+                      <a:noFill/>
+                    </a:lnT>
+                    <a:lnB w="9525" cap="flat" cmpd="sng" algn="ctr">
+                      <a:solidFill>
+                        <a:srgbClr val="BFBFBF"/>
+                      </a:solidFill>
+                      <a:prstDash val="solid"/>
+                      <a:round/>
+                      <a:headEnd type="none" w="med" len="med"/>
+                      <a:tailEnd type="none" w="med" len="med"/>
+                    </a:lnB>
+                    <a:solidFill>
+                      <a:srgbClr val="FFFFFF"/>
+                    </a:solidFill>
+                  </a:tcPr>
+                </a:tc>
+              </a:tr>
+              <a:tr h="237744">
+                <a:tc>
+                  <a:txBody>
+                    <a:bodyPr/>
+                    <a:lstStyle/>
+                    <a:p>
+                      <a:pPr algn="l" indent="0" marL="0">
+                        <a:buNone/>
+                      </a:pPr>
+                      <a:r>
+                        <a:rPr lang="en-US" sz="800" dirty="0">
+                          <a:solidFill>
+                            <a:srgbClr val="1A1A1A"/>
+                          </a:solidFill>
+                          <a:latin typeface="Meiryo" pitchFamily="34" charset="0"/>
+                          <a:ea typeface="Meiryo" pitchFamily="34" charset="-122"/>
+                          <a:cs typeface="Meiryo" pitchFamily="34" charset="-120"/>
+                        </a:rPr>
+                        <a:t>1.5億円は多すぎない？</a:t>
+                      </a:r>
+                      <a:endParaRPr lang="en-US" sz="800" dirty="0">
+                        <a:latin typeface="Meiryo" charset="0"/>
+                        <a:ea typeface="Meiryo" charset="0"/>
+                        <a:cs typeface="Meiryo" charset="0"/>
+                      </a:endParaRPr>
+                    </a:p>
+                  </a:txBody>
+                  <a:tcPr marL="54864" marR="54864" marT="18288" marB="18288" anchor="ctr">
+                    <a:lnL w="0" cap="flat" cmpd="sng" algn="ctr">
+                      <a:noFill/>
+                    </a:lnL>
+                    <a:lnR w="0" cap="flat" cmpd="sng" algn="ctr">
+                      <a:noFill/>
+                    </a:lnR>
+                    <a:lnT w="0" cap="flat" cmpd="sng" algn="ctr">
+                      <a:noFill/>
+                    </a:lnT>
+                    <a:lnB w="9525" cap="flat" cmpd="sng" algn="ctr">
+                      <a:solidFill>
+                        <a:srgbClr val="BFBFBF"/>
+                      </a:solidFill>
+                      <a:prstDash val="solid"/>
+                      <a:round/>
+                      <a:headEnd type="none" w="med" len="med"/>
+                      <a:tailEnd type="none" w="med" len="med"/>
+                    </a:lnB>
+                    <a:solidFill>
+                      <a:srgbClr val="FFFFFF"/>
+                    </a:solidFill>
+                  </a:tcPr>
+                </a:tc>
+                <a:tc>
+                  <a:txBody>
+                    <a:bodyPr/>
+                    <a:lstStyle/>
+                    <a:p>
+                      <a:pPr algn="l" indent="0" marL="0">
+                        <a:buNone/>
+                      </a:pPr>
+                      <a:r>
+                        <a:rPr lang="en-US" sz="800" dirty="0">
+                          <a:solidFill>
+                            <a:srgbClr val="1A1A1A"/>
+                          </a:solidFill>
+                          <a:latin typeface="Meiryo" pitchFamily="34" charset="0"/>
+                          <a:ea typeface="Meiryo" pitchFamily="34" charset="-122"/>
+                          <a:cs typeface="Meiryo" pitchFamily="34" charset="-120"/>
+                        </a:rPr>
+                        <a:t>赤字のピーク・運転資金・1年遅れの備えを積んだ額です</a:t>
+                      </a:r>
+                      <a:endParaRPr lang="en-US" sz="800" dirty="0">
+                        <a:latin typeface="Meiryo" charset="0"/>
+                        <a:ea typeface="Meiryo" charset="0"/>
+                        <a:cs typeface="Meiryo" charset="0"/>
+                      </a:endParaRPr>
+                    </a:p>
+                  </a:txBody>
+                  <a:tcPr marL="54864" marR="54864" marT="18288" marB="18288" anchor="ctr">
+                    <a:lnL w="0" cap="flat" cmpd="sng" algn="ctr">
+                      <a:noFill/>
+                    </a:lnL>
+                    <a:lnR w="0" cap="flat" cmpd="sng" algn="ctr">
+                      <a:noFill/>
+                    </a:lnR>
+                    <a:lnT w="0" cap="flat" cmpd="sng" algn="ctr">
+                      <a:noFill/>
+                    </a:lnT>
+                    <a:lnB w="9525" cap="flat" cmpd="sng" algn="ctr">
+                      <a:solidFill>
+                        <a:srgbClr val="BFBFBF"/>
+                      </a:solidFill>
+                      <a:prstDash val="solid"/>
+                      <a:round/>
+                      <a:headEnd type="none" w="med" len="med"/>
+                      <a:tailEnd type="none" w="med" len="med"/>
+                    </a:lnB>
+                    <a:solidFill>
+                      <a:srgbClr val="FFFFFF"/>
+                    </a:solidFill>
+                  </a:tcPr>
+                </a:tc>
+                <a:tc>
+                  <a:txBody>
+                    <a:bodyPr/>
+                    <a:lstStyle/>
+                    <a:p>
+                      <a:pPr algn="ctr" indent="0" marL="0">
+                        <a:buNone/>
+                      </a:pPr>
+                      <a:r>
+                        <a:rPr lang="en-US" sz="800" dirty="0">
+                          <a:solidFill>
+                            <a:srgbClr val="1A1A1A"/>
+                          </a:solidFill>
+                          <a:latin typeface="Meiryo" pitchFamily="34" charset="0"/>
+                          <a:ea typeface="Meiryo" pitchFamily="34" charset="-122"/>
+                          <a:cs typeface="Meiryo" pitchFamily="34" charset="-120"/>
+                        </a:rPr>
+                        <a:t>根拠10</a:t>
+                      </a:r>
+                      <a:endParaRPr lang="en-US" sz="800" dirty="0">
+                        <a:latin typeface="Meiryo" charset="0"/>
+                        <a:ea typeface="Meiryo" charset="0"/>
+                        <a:cs typeface="Meiryo" charset="0"/>
+                      </a:endParaRPr>
+                    </a:p>
+                  </a:txBody>
+                  <a:tcPr marL="54864" marR="54864" marT="18288" marB="18288" anchor="ctr">
+                    <a:lnL w="0" cap="flat" cmpd="sng" algn="ctr">
+                      <a:noFill/>
+                    </a:lnL>
+                    <a:lnR w="0" cap="flat" cmpd="sng" algn="ctr">
+                      <a:noFill/>
+                    </a:lnR>
+                    <a:lnT w="0" cap="flat" cmpd="sng" algn="ctr">
+                      <a:noFill/>
+                    </a:lnT>
+                    <a:lnB w="9525" cap="flat" cmpd="sng" algn="ctr">
+                      <a:solidFill>
+                        <a:srgbClr val="BFBFBF"/>
+                      </a:solidFill>
+                      <a:prstDash val="solid"/>
+                      <a:round/>
+                      <a:headEnd type="none" w="med" len="med"/>
+                      <a:tailEnd type="none" w="med" len="med"/>
+                    </a:lnB>
+                    <a:solidFill>
+                      <a:srgbClr val="FFFFFF"/>
+                    </a:solidFill>
+                  </a:tcPr>
+                </a:tc>
+              </a:tr>
+              <a:tr h="237744">
+                <a:tc>
+                  <a:txBody>
+                    <a:bodyPr/>
+                    <a:lstStyle/>
+                    <a:p>
+                      <a:pPr algn="l" indent="0" marL="0">
+                        <a:buNone/>
+                      </a:pPr>
+                      <a:r>
+                        <a:rPr lang="en-US" sz="800" dirty="0">
+                          <a:solidFill>
+                            <a:srgbClr val="1A1A1A"/>
+                          </a:solidFill>
+                          <a:latin typeface="Meiryo" pitchFamily="34" charset="0"/>
+                          <a:ea typeface="Meiryo" pitchFamily="34" charset="-122"/>
+                          <a:cs typeface="Meiryo" pitchFamily="34" charset="-120"/>
+                        </a:rPr>
+                        <a:t>市場が小さくない？</a:t>
+                      </a:r>
+                      <a:endParaRPr lang="en-US" sz="800" dirty="0">
+                        <a:latin typeface="Meiryo" charset="0"/>
+                        <a:ea typeface="Meiryo" charset="0"/>
+                        <a:cs typeface="Meiryo" charset="0"/>
+                      </a:endParaRPr>
+                    </a:p>
+                  </a:txBody>
+                  <a:tcPr marL="54864" marR="54864" marT="18288" marB="18288" anchor="ctr">
+                    <a:lnL w="0" cap="flat" cmpd="sng" algn="ctr">
+                      <a:noFill/>
+                    </a:lnL>
+                    <a:lnR w="0" cap="flat" cmpd="sng" algn="ctr">
+                      <a:noFill/>
+                    </a:lnR>
+                    <a:lnT w="0" cap="flat" cmpd="sng" algn="ctr">
+                      <a:noFill/>
+                    </a:lnT>
+                    <a:lnB w="9525" cap="flat" cmpd="sng" algn="ctr">
+                      <a:solidFill>
+                        <a:srgbClr val="BFBFBF"/>
+                      </a:solidFill>
+                      <a:prstDash val="solid"/>
+                      <a:round/>
+                      <a:headEnd type="none" w="med" len="med"/>
+                      <a:tailEnd type="none" w="med" len="med"/>
+                    </a:lnB>
+                    <a:solidFill>
+                      <a:srgbClr val="FFFFFF"/>
+                    </a:solidFill>
+                  </a:tcPr>
+                </a:tc>
+                <a:tc>
+                  <a:txBody>
+                    <a:bodyPr/>
+                    <a:lstStyle/>
+                    <a:p>
+                      <a:pPr algn="l" indent="0" marL="0">
+                        <a:buNone/>
+                      </a:pPr>
+                      <a:r>
+                        <a:rPr lang="en-US" sz="800" dirty="0">
+                          <a:solidFill>
+                            <a:srgbClr val="1A1A1A"/>
+                          </a:solidFill>
+                          <a:latin typeface="Meiryo" pitchFamily="34" charset="0"/>
+                          <a:ea typeface="Meiryo" pitchFamily="34" charset="-122"/>
+                          <a:cs typeface="Meiryo" pitchFamily="34" charset="-120"/>
+                        </a:rPr>
+                        <a:t>5年目でターゲット市場の約1.8%。工場と海外は含めていません</a:t>
+                      </a:r>
+                      <a:endParaRPr lang="en-US" sz="800" dirty="0">
+                        <a:latin typeface="Meiryo" charset="0"/>
+                        <a:ea typeface="Meiryo" charset="0"/>
+                        <a:cs typeface="Meiryo" charset="0"/>
+                      </a:endParaRPr>
+                    </a:p>
+                  </a:txBody>
+                  <a:tcPr marL="54864" marR="54864" marT="18288" marB="18288" anchor="ctr">
+                    <a:lnL w="0" cap="flat" cmpd="sng" algn="ctr">
+                      <a:noFill/>
+                    </a:lnL>
+                    <a:lnR w="0" cap="flat" cmpd="sng" algn="ctr">
+                      <a:noFill/>
+                    </a:lnR>
+                    <a:lnT w="0" cap="flat" cmpd="sng" algn="ctr">
+                      <a:noFill/>
+                    </a:lnT>
+                    <a:lnB w="9525" cap="flat" cmpd="sng" algn="ctr">
+                      <a:solidFill>
+                        <a:srgbClr val="BFBFBF"/>
+                      </a:solidFill>
+                      <a:prstDash val="solid"/>
+                      <a:round/>
+                      <a:headEnd type="none" w="med" len="med"/>
+                      <a:tailEnd type="none" w="med" len="med"/>
+                    </a:lnB>
+                    <a:solidFill>
+                      <a:srgbClr val="FFFFFF"/>
+                    </a:solidFill>
+                  </a:tcPr>
+                </a:tc>
+                <a:tc>
+                  <a:txBody>
+                    <a:bodyPr/>
+                    <a:lstStyle/>
+                    <a:p>
+                      <a:pPr algn="ctr" indent="0" marL="0">
+                        <a:buNone/>
+                      </a:pPr>
+                      <a:r>
+                        <a:rPr lang="en-US" sz="800" dirty="0">
+                          <a:solidFill>
+                            <a:srgbClr val="1A1A1A"/>
+                          </a:solidFill>
+                          <a:latin typeface="Meiryo" pitchFamily="34" charset="0"/>
+                          <a:ea typeface="Meiryo" pitchFamily="34" charset="-122"/>
+                          <a:cs typeface="Meiryo" pitchFamily="34" charset="-120"/>
+                        </a:rPr>
+                        <a:t>根拠11</a:t>
+                      </a:r>
+                      <a:endParaRPr lang="en-US" sz="800" dirty="0">
+                        <a:latin typeface="Meiryo" charset="0"/>
+                        <a:ea typeface="Meiryo" charset="0"/>
+                        <a:cs typeface="Meiryo" charset="0"/>
+                      </a:endParaRPr>
+                    </a:p>
+                  </a:txBody>
+                  <a:tcPr marL="54864" marR="54864" marT="18288" marB="18288" anchor="ctr">
+                    <a:lnL w="0" cap="flat" cmpd="sng" algn="ctr">
+                      <a:noFill/>
+                    </a:lnL>
+                    <a:lnR w="0" cap="flat" cmpd="sng" algn="ctr">
+                      <a:noFill/>
+                    </a:lnR>
+                    <a:lnT w="0" cap="flat" cmpd="sng" algn="ctr">
+                      <a:noFill/>
+                    </a:lnT>
+                    <a:lnB w="9525" cap="flat" cmpd="sng" algn="ctr">
+                      <a:solidFill>
+                        <a:srgbClr val="BFBFBF"/>
+                      </a:solidFill>
+                      <a:prstDash val="solid"/>
+                      <a:round/>
+                      <a:headEnd type="none" w="med" len="med"/>
+                      <a:tailEnd type="none" w="med" len="med"/>
+                    </a:lnB>
+                    <a:solidFill>
+                      <a:srgbClr val="FFFFFF"/>
+                    </a:solidFill>
+                  </a:tcPr>
+                </a:tc>
+              </a:tr>
+              <a:tr h="237744">
+                <a:tc>
+                  <a:txBody>
+                    <a:bodyPr/>
+                    <a:lstStyle/>
+                    <a:p>
+                      <a:pPr algn="l" indent="0" marL="0">
+                        <a:buNone/>
+                      </a:pPr>
+                      <a:r>
+                        <a:rPr lang="en-US" sz="800" dirty="0">
+                          <a:solidFill>
+                            <a:srgbClr val="1A1A1A"/>
+                          </a:solidFill>
+                          <a:latin typeface="Meiryo" pitchFamily="34" charset="0"/>
+                          <a:ea typeface="Meiryo" pitchFamily="34" charset="-122"/>
+                          <a:cs typeface="Meiryo" pitchFamily="34" charset="-120"/>
+                        </a:rPr>
+                        <a:t>グラスは開発できるのか？</a:t>
+                      </a:r>
+                      <a:endParaRPr lang="en-US" sz="800" dirty="0">
+                        <a:latin typeface="Meiryo" charset="0"/>
+                        <a:ea typeface="Meiryo" charset="0"/>
+                        <a:cs typeface="Meiryo" charset="0"/>
+                      </a:endParaRPr>
+                    </a:p>
+                  </a:txBody>
+                  <a:tcPr marL="54864" marR="54864" marT="18288" marB="18288" anchor="ctr">
+                    <a:lnL w="0" cap="flat" cmpd="sng" algn="ctr">
+                      <a:noFill/>
+                    </a:lnL>
+                    <a:lnR w="0" cap="flat" cmpd="sng" algn="ctr">
+                      <a:noFill/>
+                    </a:lnR>
+                    <a:lnT w="0" cap="flat" cmpd="sng" algn="ctr">
+                      <a:noFill/>
+                    </a:lnT>
+                    <a:lnB w="9525" cap="flat" cmpd="sng" algn="ctr">
+                      <a:solidFill>
+                        <a:srgbClr val="BFBFBF"/>
+                      </a:solidFill>
+                      <a:prstDash val="solid"/>
+                      <a:round/>
+                      <a:headEnd type="none" w="med" len="med"/>
+                      <a:tailEnd type="none" w="med" len="med"/>
+                    </a:lnB>
+                    <a:solidFill>
+                      <a:srgbClr val="FFFFFF"/>
+                    </a:solidFill>
+                  </a:tcPr>
+                </a:tc>
+                <a:tc>
+                  <a:txBody>
+                    <a:bodyPr/>
+                    <a:lstStyle/>
+                    <a:p>
+                      <a:pPr algn="l" indent="0" marL="0">
+                        <a:buNone/>
+                      </a:pPr>
+                      <a:r>
+                        <a:rPr lang="en-US" sz="800" dirty="0">
+                          <a:solidFill>
+                            <a:srgbClr val="1A1A1A"/>
+                          </a:solidFill>
+                          <a:latin typeface="Meiryo" pitchFamily="34" charset="0"/>
+                          <a:ea typeface="Meiryo" pitchFamily="34" charset="-122"/>
+                          <a:cs typeface="Meiryo" pitchFamily="34" charset="-120"/>
+                        </a:rPr>
+                        <a:t>作りません。市販の端末を現場仕様にし、乗り換えられる設計にします</a:t>
+                      </a:r>
+                      <a:endParaRPr lang="en-US" sz="800" dirty="0">
+                        <a:latin typeface="Meiryo" charset="0"/>
+                        <a:ea typeface="Meiryo" charset="0"/>
+                        <a:cs typeface="Meiryo" charset="0"/>
+                      </a:endParaRPr>
+                    </a:p>
+                  </a:txBody>
+                  <a:tcPr marL="54864" marR="54864" marT="18288" marB="18288" anchor="ctr">
+                    <a:lnL w="0" cap="flat" cmpd="sng" algn="ctr">
+                      <a:noFill/>
+                    </a:lnL>
+                    <a:lnR w="0" cap="flat" cmpd="sng" algn="ctr">
+                      <a:noFill/>
+                    </a:lnR>
+                    <a:lnT w="0" cap="flat" cmpd="sng" algn="ctr">
+                      <a:noFill/>
+                    </a:lnT>
+                    <a:lnB w="9525" cap="flat" cmpd="sng" algn="ctr">
+                      <a:solidFill>
+                        <a:srgbClr val="BFBFBF"/>
+                      </a:solidFill>
+                      <a:prstDash val="solid"/>
+                      <a:round/>
+                      <a:headEnd type="none" w="med" len="med"/>
+                      <a:tailEnd type="none" w="med" len="med"/>
+                    </a:lnB>
+                    <a:solidFill>
+                      <a:srgbClr val="FFFFFF"/>
+                    </a:solidFill>
+                  </a:tcPr>
+                </a:tc>
+                <a:tc>
+                  <a:txBody>
+                    <a:bodyPr/>
+                    <a:lstStyle/>
+                    <a:p>
+                      <a:pPr algn="ctr" indent="0" marL="0">
+                        <a:buNone/>
+                      </a:pPr>
+                      <a:r>
+                        <a:rPr lang="en-US" sz="800" dirty="0">
+                          <a:solidFill>
+                            <a:srgbClr val="1A1A1A"/>
+                          </a:solidFill>
+                          <a:latin typeface="Meiryo" pitchFamily="34" charset="0"/>
+                          <a:ea typeface="Meiryo" pitchFamily="34" charset="-122"/>
+                          <a:cs typeface="Meiryo" pitchFamily="34" charset="-120"/>
+                        </a:rPr>
+                        <a:t>根拠13</a:t>
+                      </a:r>
+                      <a:endParaRPr lang="en-US" sz="800" dirty="0">
+                        <a:latin typeface="Meiryo" charset="0"/>
+                        <a:ea typeface="Meiryo" charset="0"/>
+                        <a:cs typeface="Meiryo" charset="0"/>
+                      </a:endParaRPr>
+                    </a:p>
+                  </a:txBody>
+                  <a:tcPr marL="54864" marR="54864" marT="18288" marB="18288" anchor="ctr">
+                    <a:lnL w="0" cap="flat" cmpd="sng" algn="ctr">
+                      <a:noFill/>
+                    </a:lnL>
+                    <a:lnR w="0" cap="flat" cmpd="sng" algn="ctr">
+                      <a:noFill/>
+                    </a:lnR>
+                    <a:lnT w="0" cap="flat" cmpd="sng" algn="ctr">
+                      <a:noFill/>
+                    </a:lnT>
+                    <a:lnB w="9525" cap="flat" cmpd="sng" algn="ctr">
+                      <a:solidFill>
+                        <a:srgbClr val="BFBFBF"/>
+                      </a:solidFill>
+                      <a:prstDash val="solid"/>
+                      <a:round/>
+                      <a:headEnd type="none" w="med" len="med"/>
+                      <a:tailEnd type="none" w="med" len="med"/>
+                    </a:lnB>
+                    <a:solidFill>
+                      <a:srgbClr val="FFFFFF"/>
+                    </a:solidFill>
+                  </a:tcPr>
+                </a:tc>
+              </a:tr>
+              <a:tr h="237744">
+                <a:tc>
+                  <a:txBody>
+                    <a:bodyPr/>
+                    <a:lstStyle/>
+                    <a:p>
+                      <a:pPr algn="l" indent="0" marL="0">
+                        <a:buNone/>
+                      </a:pPr>
+                      <a:r>
+                        <a:rPr lang="en-US" sz="800" dirty="0">
+                          <a:solidFill>
+                            <a:srgbClr val="1A1A1A"/>
+                          </a:solidFill>
+                          <a:latin typeface="Meiryo" pitchFamily="34" charset="0"/>
+                          <a:ea typeface="Meiryo" pitchFamily="34" charset="-122"/>
+                          <a:cs typeface="Meiryo" pitchFamily="34" charset="-120"/>
+                        </a:rPr>
+                        <a:t>ARの位置ずれは？</a:t>
+                      </a:r>
+                      <a:endParaRPr lang="en-US" sz="800" dirty="0">
+                        <a:latin typeface="Meiryo" charset="0"/>
+                        <a:ea typeface="Meiryo" charset="0"/>
+                        <a:cs typeface="Meiryo" charset="0"/>
+                      </a:endParaRPr>
+                    </a:p>
+                  </a:txBody>
+                  <a:tcPr marL="54864" marR="54864" marT="18288" marB="18288" anchor="ctr">
+                    <a:lnL w="0" cap="flat" cmpd="sng" algn="ctr">
+                      <a:noFill/>
+                    </a:lnL>
+                    <a:lnR w="0" cap="flat" cmpd="sng" algn="ctr">
+                      <a:noFill/>
+                    </a:lnR>
+                    <a:lnT w="0" cap="flat" cmpd="sng" algn="ctr">
+                      <a:noFill/>
+                    </a:lnT>
+                    <a:lnB w="9525" cap="flat" cmpd="sng" algn="ctr">
+                      <a:solidFill>
+                        <a:srgbClr val="BFBFBF"/>
+                      </a:solidFill>
+                      <a:prstDash val="solid"/>
+                      <a:round/>
+                      <a:headEnd type="none" w="med" len="med"/>
+                      <a:tailEnd type="none" w="med" len="med"/>
+                    </a:lnB>
+                    <a:solidFill>
+                      <a:srgbClr val="FFFFFF"/>
+                    </a:solidFill>
+                  </a:tcPr>
+                </a:tc>
+                <a:tc>
+                  <a:txBody>
+                    <a:bodyPr/>
+                    <a:lstStyle/>
+                    <a:p>
+                      <a:pPr algn="l" indent="0" marL="0">
+                        <a:buNone/>
+                      </a:pPr>
+                      <a:r>
+                        <a:rPr lang="en-US" sz="800" dirty="0">
+                          <a:solidFill>
+                            <a:srgbClr val="1A1A1A"/>
+                          </a:solidFill>
+                          <a:latin typeface="Meiryo" pitchFamily="34" charset="0"/>
+                          <a:ea typeface="Meiryo" pitchFamily="34" charset="-122"/>
+                          <a:cs typeface="Meiryo" pitchFamily="34" charset="-120"/>
+                        </a:rPr>
+                        <a:t>数mm〜cmずれます。最終確認はスケール。間違いに気づく道具です</a:t>
+                      </a:r>
+                      <a:endParaRPr lang="en-US" sz="800" dirty="0">
+                        <a:latin typeface="Meiryo" charset="0"/>
+                        <a:ea typeface="Meiryo" charset="0"/>
+                        <a:cs typeface="Meiryo" charset="0"/>
+                      </a:endParaRPr>
+                    </a:p>
+                  </a:txBody>
+                  <a:tcPr marL="54864" marR="54864" marT="18288" marB="18288" anchor="ctr">
+                    <a:lnL w="0" cap="flat" cmpd="sng" algn="ctr">
+                      <a:noFill/>
+                    </a:lnL>
+                    <a:lnR w="0" cap="flat" cmpd="sng" algn="ctr">
+                      <a:noFill/>
+                    </a:lnR>
+                    <a:lnT w="0" cap="flat" cmpd="sng" algn="ctr">
+                      <a:noFill/>
+                    </a:lnT>
+                    <a:lnB w="9525" cap="flat" cmpd="sng" algn="ctr">
+                      <a:solidFill>
+                        <a:srgbClr val="BFBFBF"/>
+                      </a:solidFill>
+                      <a:prstDash val="solid"/>
+                      <a:round/>
+                      <a:headEnd type="none" w="med" len="med"/>
+                      <a:tailEnd type="none" w="med" len="med"/>
+                    </a:lnB>
+                    <a:solidFill>
+                      <a:srgbClr val="FFFFFF"/>
+                    </a:solidFill>
+                  </a:tcPr>
+                </a:tc>
+                <a:tc>
+                  <a:txBody>
+                    <a:bodyPr/>
+                    <a:lstStyle/>
+                    <a:p>
+                      <a:pPr algn="ctr" indent="0" marL="0">
+                        <a:buNone/>
+                      </a:pPr>
+                      <a:r>
+                        <a:rPr lang="en-US" sz="800" dirty="0">
+                          <a:solidFill>
+                            <a:srgbClr val="1A1A1A"/>
+                          </a:solidFill>
+                          <a:latin typeface="Meiryo" pitchFamily="34" charset="0"/>
+                          <a:ea typeface="Meiryo" pitchFamily="34" charset="-122"/>
+                          <a:cs typeface="Meiryo" pitchFamily="34" charset="-120"/>
+                        </a:rPr>
+                        <a:t>根拠13</a:t>
+                      </a:r>
+                      <a:endParaRPr lang="en-US" sz="800" dirty="0">
+                        <a:latin typeface="Meiryo" charset="0"/>
+                        <a:ea typeface="Meiryo" charset="0"/>
+                        <a:cs typeface="Meiryo" charset="0"/>
+                      </a:endParaRPr>
+                    </a:p>
+                  </a:txBody>
+                  <a:tcPr marL="54864" marR="54864" marT="18288" marB="18288" anchor="ctr">
+                    <a:lnL w="0" cap="flat" cmpd="sng" algn="ctr">
+                      <a:noFill/>
+                    </a:lnL>
+                    <a:lnR w="0" cap="flat" cmpd="sng" algn="ctr">
+                      <a:noFill/>
+                    </a:lnR>
+                    <a:lnT w="0" cap="flat" cmpd="sng" algn="ctr">
+                      <a:noFill/>
+                    </a:lnT>
+                    <a:lnB w="9525" cap="flat" cmpd="sng" algn="ctr">
+                      <a:solidFill>
+                        <a:srgbClr val="BFBFBF"/>
+                      </a:solidFill>
+                      <a:prstDash val="solid"/>
+                      <a:round/>
+                      <a:headEnd type="none" w="med" len="med"/>
+                      <a:tailEnd type="none" w="med" len="med"/>
+                    </a:lnB>
+                    <a:solidFill>
+                      <a:srgbClr val="FFFFFF"/>
+                    </a:solidFill>
+                  </a:tcPr>
+                </a:tc>
+              </a:tr>
+              <a:tr h="237744">
+                <a:tc>
+                  <a:txBody>
+                    <a:bodyPr/>
+                    <a:lstStyle/>
+                    <a:p>
+                      <a:pPr algn="l" indent="0" marL="0">
+                        <a:buNone/>
+                      </a:pPr>
+                      <a:r>
+                        <a:rPr lang="en-US" sz="800" dirty="0">
+                          <a:solidFill>
+                            <a:srgbClr val="1A1A1A"/>
+                          </a:solidFill>
+                          <a:latin typeface="Meiryo" pitchFamily="34" charset="0"/>
+                          <a:ea typeface="Meiryo" pitchFamily="34" charset="-122"/>
+                          <a:cs typeface="Meiryo" pitchFamily="34" charset="-120"/>
+                        </a:rPr>
+                        <a:t>あなたが倒れたら？</a:t>
+                      </a:r>
+                      <a:endParaRPr lang="en-US" sz="800" dirty="0">
+                        <a:latin typeface="Meiryo" charset="0"/>
+                        <a:ea typeface="Meiryo" charset="0"/>
+                        <a:cs typeface="Meiryo" charset="0"/>
+                      </a:endParaRPr>
+                    </a:p>
+                  </a:txBody>
+                  <a:tcPr marL="54864" marR="54864" marT="18288" marB="18288" anchor="ctr">
+                    <a:lnL w="0" cap="flat" cmpd="sng" algn="ctr">
+                      <a:noFill/>
+                    </a:lnL>
+                    <a:lnR w="0" cap="flat" cmpd="sng" algn="ctr">
+                      <a:noFill/>
+                    </a:lnR>
+                    <a:lnT w="0" cap="flat" cmpd="sng" algn="ctr">
+                      <a:noFill/>
+                    </a:lnT>
+                    <a:lnB w="9525" cap="flat" cmpd="sng" algn="ctr">
+                      <a:solidFill>
+                        <a:srgbClr val="BFBFBF"/>
+                      </a:solidFill>
+                      <a:prstDash val="solid"/>
+                      <a:round/>
+                      <a:headEnd type="none" w="med" len="med"/>
+                      <a:tailEnd type="none" w="med" len="med"/>
+                    </a:lnB>
+                    <a:solidFill>
+                      <a:srgbClr val="FFFFFF"/>
+                    </a:solidFill>
+                  </a:tcPr>
+                </a:tc>
+                <a:tc>
+                  <a:txBody>
+                    <a:bodyPr/>
+                    <a:lstStyle/>
+                    <a:p>
+                      <a:pPr algn="l" indent="0" marL="0">
+                        <a:buNone/>
+                      </a:pPr>
+                      <a:r>
+                        <a:rPr lang="en-US" sz="800" dirty="0">
+                          <a:solidFill>
+                            <a:srgbClr val="1A1A1A"/>
+                          </a:solidFill>
+                          <a:latin typeface="Meiryo" pitchFamily="34" charset="0"/>
+                          <a:ea typeface="Meiryo" pitchFamily="34" charset="-122"/>
+                          <a:cs typeface="Meiryo" pitchFamily="34" charset="-120"/>
+                        </a:rPr>
+                        <a:t>役割を絞り判断基準を先に決め、1か月不在でも回る形にします</a:t>
+                      </a:r>
+                      <a:endParaRPr lang="en-US" sz="800" dirty="0">
+                        <a:latin typeface="Meiryo" charset="0"/>
+                        <a:ea typeface="Meiryo" charset="0"/>
+                        <a:cs typeface="Meiryo" charset="0"/>
+                      </a:endParaRPr>
+                    </a:p>
+                  </a:txBody>
+                  <a:tcPr marL="54864" marR="54864" marT="18288" marB="18288" anchor="ctr">
+                    <a:lnL w="0" cap="flat" cmpd="sng" algn="ctr">
+                      <a:noFill/>
+                    </a:lnL>
+                    <a:lnR w="0" cap="flat" cmpd="sng" algn="ctr">
+                      <a:noFill/>
+                    </a:lnR>
+                    <a:lnT w="0" cap="flat" cmpd="sng" algn="ctr">
+                      <a:noFill/>
+                    </a:lnT>
+                    <a:lnB w="9525" cap="flat" cmpd="sng" algn="ctr">
+                      <a:solidFill>
+                        <a:srgbClr val="BFBFBF"/>
+                      </a:solidFill>
+                      <a:prstDash val="solid"/>
+                      <a:round/>
+                      <a:headEnd type="none" w="med" len="med"/>
+                      <a:tailEnd type="none" w="med" len="med"/>
+                    </a:lnB>
+                    <a:solidFill>
+                      <a:srgbClr val="FFFFFF"/>
+                    </a:solidFill>
+                  </a:tcPr>
+                </a:tc>
+                <a:tc>
+                  <a:txBody>
+                    <a:bodyPr/>
+                    <a:lstStyle/>
+                    <a:p>
+                      <a:pPr algn="ctr" indent="0" marL="0">
+                        <a:buNone/>
+                      </a:pPr>
+                      <a:r>
+                        <a:rPr lang="en-US" sz="800" dirty="0">
+                          <a:solidFill>
+                            <a:srgbClr val="1A1A1A"/>
+                          </a:solidFill>
+                          <a:latin typeface="Meiryo" pitchFamily="34" charset="0"/>
+                          <a:ea typeface="Meiryo" pitchFamily="34" charset="-122"/>
+                          <a:cs typeface="Meiryo" pitchFamily="34" charset="-120"/>
+                        </a:rPr>
+                        <a:t>発表資料リスク</a:t>
+                      </a:r>
+                      <a:endParaRPr lang="en-US" sz="800" dirty="0">
+                        <a:latin typeface="Meiryo" charset="0"/>
+                        <a:ea typeface="Meiryo" charset="0"/>
+                        <a:cs typeface="Meiryo" charset="0"/>
+                      </a:endParaRPr>
+                    </a:p>
+                  </a:txBody>
+                  <a:tcPr marL="54864" marR="54864" marT="18288" marB="18288" anchor="ctr">
+                    <a:lnL w="0" cap="flat" cmpd="sng" algn="ctr">
+                      <a:noFill/>
+                    </a:lnL>
+                    <a:lnR w="0" cap="flat" cmpd="sng" algn="ctr">
+                      <a:noFill/>
+                    </a:lnR>
+                    <a:lnT w="0" cap="flat" cmpd="sng" algn="ctr">
+                      <a:noFill/>
+                    </a:lnT>
+                    <a:lnB w="9525" cap="flat" cmpd="sng" algn="ctr">
+                      <a:solidFill>
+                        <a:srgbClr val="BFBFBF"/>
+                      </a:solidFill>
+                      <a:prstDash val="solid"/>
+                      <a:round/>
+                      <a:headEnd type="none" w="med" len="med"/>
+                      <a:tailEnd type="none" w="med" len="med"/>
+                    </a:lnB>
+                    <a:solidFill>
+                      <a:srgbClr val="FFFFFF"/>
+                    </a:solidFill>
+                  </a:tcPr>
+                </a:tc>
+              </a:tr>
+            </a:tbl>
+          </a:graphicData>
+        </a:graphic>
+      </p:graphicFrame>
+      <p:sp>
+        <p:nvSpPr>
+          <p:cNvPr id="6" name="Text 2"/>
+          <p:cNvSpPr txBox="1"/>
+          <p:nvPr/>
+        </p:nvSpPr>
+        <p:spPr>
+          <a:xfrm>
+            <a:off x="365760" y="4553712"/>
+            <a:ext cx="8412480" cy="237744"/>
+          </a:xfrm>
+          <a:prstGeom prst="rect">
+            <a:avLst/>
+          </a:prstGeom>
+          <a:noFill/>
+          <a:ln/>
+        </p:spPr>
+        <p:txBody>
+          <a:bodyPr wrap="square" lIns="0" tIns="0" rIns="0" bIns="0" rtlCol="0" anchor="t"/>
+          <a:lstStyle/>
+          <a:p>
+            <a:pPr algn="l" indent="0" marL="0">
+              <a:lnSpc>
+                <a:spcPct val="115000"/>
+              </a:lnSpc>
+              <a:buNone/>
+            </a:pPr>
+            <a:r>
+              <a:rPr lang="en-US" sz="800" dirty="0">
+                <a:solidFill>
+                  <a:srgbClr val="8C8C8C"/>
+                </a:solidFill>
+                <a:latin typeface="Meiryo" pitchFamily="34" charset="0"/>
+                <a:ea typeface="Meiryo" pitchFamily="34" charset="-122"/>
+                <a:cs typeface="Meiryo" pitchFamily="34" charset="-120"/>
+              </a:rPr>
+              <a:t>詳しい想定問答は「令和の虎_想定問答.md」</a:t>
+            </a:r>
+            <a:endParaRPr lang="en-US" sz="800" dirty="0"/>
+          </a:p>
+        </p:txBody>
+      </p:sp>
+      <p:sp>
+        <p:nvSpPr>
+          <p:cNvPr id="25" name="Slide Number Placeholder 0"/>
+          <p:cNvSpPr>
+            <a:spLocks noGrp="1"/>
+          </p:cNvSpPr>
+          <p:nvPr>
+            <p:ph type="sldNum" sz="quarter" idx="4294967295"/>
+          </p:nvPr>
+        </p:nvSpPr>
+        <p:spPr>
+          <a:xfrm>
+            <a:off x="365760" y="4837176"/>
+            <a:ext cx="320040" cy="201168"/>
+          </a:xfrm>
+          <a:prstGeom prst="rect">
+            <a:avLst/>
+          </a:prstGeom>
+          <a:extLst>
+            <a:ext uri="{C572A759-6A51-4108-AA02-DFA0A04FC94B}">
+              <ma14:wrappingTextBoxFlag xmlns:ma14="http://schemas.microsoft.com/office/mac/drawingml/2011/main" val="0"/>
+            </a:ext>
+          </a:extLst>
+        </p:spPr>
+        <p:txBody>
+          <a:bodyPr lIns="0" tIns="0" rIns="0" bIns="0"/>
+          <a:lstStyle>
+            <a:lvl1pPr>
+              <a:defRPr sz="850">
+                <a:solidFill>
+                  <a:srgbClr val="8C8C8C"/>
+                </a:solidFill>
+                <a:latin typeface="Meiryo"/>
+                <a:ea typeface="Meiryo"/>
+                <a:cs typeface="Meiryo"/>
+              </a:defRPr>
+            </a:lvl1pPr>
+          </a:lstStyle>
+          <a:p>
+            <a:pPr algn="l"/>
+            <a:fld id="{F7021451-1387-4CA6-816F-3879F97B5CBC}" type="slidenum">
+              <a:rPr b="0" lang="en-US"/>
+              <a:t>15</a:t>
+            </a:fld>
+            <a:endParaRPr lang="en-US"/>
+          </a:p>
+        </p:txBody>
+      </p:sp>
+    </p:spTree>
+  </p:cSld>
+  <p:clrMapOvr>
+    <a:masterClrMapping/>
+  </p:clrMapOvr>
+</p:sld>
+</file>
+
+<file path=ppt/slides/slide16.xml><?xml version="1.0" encoding="utf-8"?>
+<p:sld xmlns:a="http://schemas.openxmlformats.org/drawingml/2006/main" xmlns:r="http://schemas.openxmlformats.org/officeDocument/2006/relationships" xmlns:p="http://schemas.openxmlformats.org/presentationml/2006/main">
+  <p:cSld name="Slide 16">
+    <p:spTree>
+      <p:nvGrpSpPr>
+        <p:cNvPr id="1" name=""/>
+        <p:cNvGrpSpPr/>
+        <p:nvPr/>
+      </p:nvGrpSpPr>
+      <p:grpSpPr>
+        <a:xfrm>
+          <a:off x="0" y="0"/>
+          <a:ext cx="0" cy="0"/>
+          <a:chOff x="0" y="0"/>
+          <a:chExt cx="0" cy="0"/>
+        </a:xfrm>
+      </p:grpSpPr>
+      <p:sp>
+        <p:nvSpPr>
+          <p:cNvPr id="3" name="title"/>
+          <p:cNvSpPr txBox="1"/>
+          <p:nvPr/>
+        </p:nvSpPr>
+        <p:spPr>
+          <a:xfrm>
+            <a:off x="365760" y="256032"/>
+            <a:ext cx="7955280" cy="384048"/>
+          </a:xfrm>
+          <a:prstGeom prst="rect">
+            <a:avLst/>
+          </a:prstGeom>
+          <a:noFill/>
+          <a:ln/>
+        </p:spPr>
+        <p:txBody>
+          <a:bodyPr wrap="square" lIns="0" tIns="0" rIns="0" bIns="0" rtlCol="0" anchor="ctr"/>
+          <a:lstStyle/>
+          <a:p>
+            <a:pPr algn="l" indent="0" marL="0">
+              <a:lnSpc>
+                <a:spcPct val="115000"/>
+              </a:lnSpc>
+              <a:buNone/>
+            </a:pPr>
+            <a:r>
+              <a:rPr lang="en-US" sz="2000" b="1" dirty="0">
+                <a:solidFill>
                   <a:srgbClr val="1A1A1A"/>
                 </a:solidFill>
                 <a:latin typeface="Meiryo" pitchFamily="34" charset="0"/>
@@ -17599,7 +19701,7 @@
       </p:sp>
       <p:graphicFrame>
         <p:nvGraphicFramePr>
-          <p:cNvPr id="16" name="sources"/>
+          <p:cNvPr id="17" name="sources"/>
           <p:cNvGraphicFramePr>
             <a:graphicFrameLocks noGrp="1"/>
           </p:cNvGraphicFramePr>
@@ -17623,7 +19725,7 @@
                 <a:gridCol w="2194560"/>
                 <a:gridCol w="6217920"/>
               </a:tblGrid>
-              <a:tr h="274320">
+              <a:tr h="256032">
                 <a:tc>
                   <a:txBody>
                     <a:bodyPr/>
@@ -17725,7 +19827,7 @@
                   </a:tcPr>
                 </a:tc>
               </a:tr>
-              <a:tr h="274320">
+              <a:tr h="256032">
                 <a:tc>
                   <a:txBody>
                     <a:bodyPr/>
@@ -17827,7 +19929,7 @@
                   </a:tcPr>
                 </a:tc>
               </a:tr>
-              <a:tr h="274320">
+              <a:tr h="256032">
                 <a:tc>
                   <a:txBody>
                     <a:bodyPr/>
@@ -17929,7 +20031,7 @@
                   </a:tcPr>
                 </a:tc>
               </a:tr>
-              <a:tr h="274320">
+              <a:tr h="256032">
                 <a:tc>
                   <a:txBody>
                     <a:bodyPr/>
@@ -18031,7 +20133,7 @@
                   </a:tcPr>
                 </a:tc>
               </a:tr>
-              <a:tr h="274320">
+              <a:tr h="256032">
                 <a:tc>
                   <a:txBody>
                     <a:bodyPr/>
@@ -18133,7 +20235,7 @@
                   </a:tcPr>
                 </a:tc>
               </a:tr>
-              <a:tr h="274320">
+              <a:tr h="256032">
                 <a:tc>
                   <a:txBody>
                     <a:bodyPr/>
@@ -18235,7 +20337,7 @@
                   </a:tcPr>
                 </a:tc>
               </a:tr>
-              <a:tr h="274320">
+              <a:tr h="256032">
                 <a:tc>
                   <a:txBody>
                     <a:bodyPr/>
@@ -18337,7 +20439,7 @@
                   </a:tcPr>
                 </a:tc>
               </a:tr>
-              <a:tr h="274320">
+              <a:tr h="256032">
                 <a:tc>
                   <a:txBody>
                     <a:bodyPr/>
@@ -18439,7 +20541,7 @@
                   </a:tcPr>
                 </a:tc>
               </a:tr>
-              <a:tr h="274320">
+              <a:tr h="256032">
                 <a:tc>
                   <a:txBody>
                     <a:bodyPr/>
@@ -18541,7 +20643,7 @@
                   </a:tcPr>
                 </a:tc>
               </a:tr>
-              <a:tr h="274320">
+              <a:tr h="256032">
                 <a:tc>
                   <a:txBody>
                     <a:bodyPr/>
@@ -18643,7 +20745,7 @@
                   </a:tcPr>
                 </a:tc>
               </a:tr>
-              <a:tr h="274320">
+              <a:tr h="256032">
                 <a:tc>
                   <a:txBody>
                     <a:bodyPr/>
@@ -18745,7 +20847,109 @@
                   </a:tcPr>
                 </a:tc>
               </a:tr>
-              <a:tr h="274320">
+              <a:tr h="256032">
+                <a:tc>
+                  <a:txBody>
+                    <a:bodyPr/>
+                    <a:lstStyle/>
+                    <a:p>
+                      <a:pPr algn="l" indent="0" marL="0">
+                        <a:buNone/>
+                      </a:pPr>
+                      <a:r>
+                        <a:rPr lang="en-US" sz="800" dirty="0">
+                          <a:solidFill>
+                            <a:srgbClr val="1A1A1A"/>
+                          </a:solidFill>
+                          <a:latin typeface="Meiryo" pitchFamily="34" charset="0"/>
+                          <a:ea typeface="Meiryo" pitchFamily="34" charset="-122"/>
+                          <a:cs typeface="Meiryo" pitchFamily="34" charset="-120"/>
+                        </a:rPr>
+                        <a:t>端末</a:t>
+                      </a:r>
+                      <a:endParaRPr lang="en-US" sz="800" dirty="0">
+                        <a:latin typeface="Meiryo" charset="0"/>
+                        <a:ea typeface="Meiryo" charset="0"/>
+                        <a:cs typeface="Meiryo" charset="0"/>
+                      </a:endParaRPr>
+                    </a:p>
+                  </a:txBody>
+                  <a:tcPr marL="54864" marR="54864" marT="18288" marB="18288" anchor="ctr">
+                    <a:lnL w="0" cap="flat" cmpd="sng" algn="ctr">
+                      <a:noFill/>
+                    </a:lnL>
+                    <a:lnR w="0" cap="flat" cmpd="sng" algn="ctr">
+                      <a:noFill/>
+                    </a:lnR>
+                    <a:lnT w="0" cap="flat" cmpd="sng" algn="ctr">
+                      <a:noFill/>
+                    </a:lnT>
+                    <a:lnB w="9525" cap="flat" cmpd="sng" algn="ctr">
+                      <a:solidFill>
+                        <a:srgbClr val="BFBFBF"/>
+                      </a:solidFill>
+                      <a:prstDash val="solid"/>
+                      <a:round/>
+                      <a:headEnd type="none" w="med" len="med"/>
+                      <a:tailEnd type="none" w="med" len="med"/>
+                    </a:lnB>
+                    <a:solidFill>
+                      <a:srgbClr val="FFFFFF"/>
+                    </a:solidFill>
+                  </a:tcPr>
+                </a:tc>
+                <a:tc>
+                  <a:txBody>
+                    <a:bodyPr/>
+                    <a:lstStyle/>
+                    <a:p>
+                      <a:pPr algn="l" indent="0" marL="0">
+                        <a:buNone/>
+                      </a:pPr>
+                      <a:r>
+                        <a:rPr lang="en-US" sz="800" dirty="0">
+                          <a:solidFill>
+                            <a:srgbClr val="1A1A1A"/>
+                          </a:solidFill>
+                          <a:latin typeface="Meiryo" pitchFamily="34" charset="0"/>
+                          <a:ea typeface="Meiryo" pitchFamily="34" charset="-122"/>
+                          <a:cs typeface="Meiryo" pitchFamily="34" charset="-120"/>
+                        </a:rPr>
+                        <a:t>RealWear Navigator 520 販売店の公表値（IP66・2m落下・電池交換）、Meta Ray-Ban Display（2025年発売）、ARグラス2027年発売の報道</a:t>
+                      </a:r>
+                      <a:endParaRPr lang="en-US" sz="800" dirty="0">
+                        <a:latin typeface="Meiryo" charset="0"/>
+                        <a:ea typeface="Meiryo" charset="0"/>
+                        <a:cs typeface="Meiryo" charset="0"/>
+                      </a:endParaRPr>
+                    </a:p>
+                  </a:txBody>
+                  <a:tcPr marL="54864" marR="54864" marT="18288" marB="18288" anchor="ctr">
+                    <a:lnL w="0" cap="flat" cmpd="sng" algn="ctr">
+                      <a:noFill/>
+                    </a:lnL>
+                    <a:lnR w="0" cap="flat" cmpd="sng" algn="ctr">
+                      <a:noFill/>
+                    </a:lnR>
+                    <a:lnT w="0" cap="flat" cmpd="sng" algn="ctr">
+                      <a:noFill/>
+                    </a:lnT>
+                    <a:lnB w="9525" cap="flat" cmpd="sng" algn="ctr">
+                      <a:solidFill>
+                        <a:srgbClr val="BFBFBF"/>
+                      </a:solidFill>
+                      <a:prstDash val="solid"/>
+                      <a:round/>
+                      <a:headEnd type="none" w="med" len="med"/>
+                      <a:tailEnd type="none" w="med" len="med"/>
+                    </a:lnB>
+                    <a:solidFill>
+                      <a:srgbClr val="FFFFFF"/>
+                    </a:solidFill>
+                  </a:tcPr>
+                </a:tc>
+              </a:tr>
+              <a:tr h="256032">
                 <a:tc>
                   <a:txBody>
                     <a:bodyPr/>
@@ -18935,7 +21139,7 @@
             <a:pPr algn="l"/>
             <a:fld id="{F7021451-1387-4CA6-816F-3879F97B5CBC}" type="slidenum">
               <a:rPr b="0" lang="en-US"/>
-              <a:t>15</a:t>
+              <a:t>16</a:t>
             </a:fld>
             <a:endParaRPr lang="en-US"/>
           </a:p>

</xml_diff>